<commit_message>
Update presentation file for enhanced content and visuals
</commit_message>
<xml_diff>
--- a/resources/presentation/build-interactive-and-visual-media-with-ai-v2.pptx
+++ b/resources/presentation/build-interactive-and-visual-media-with-ai-v2.pptx
@@ -147,2000 +147,9 @@
 <file path=ppt/revisionInfo.xml><?xml version="1.0" encoding="utf-8"?>
 <p1510:revInfo xmlns:a="http://schemas.openxmlformats.org/drawingml/2006/main" xmlns:r="http://schemas.openxmlformats.org/officeDocument/2006/relationships" xmlns:p1510="http://schemas.microsoft.com/office/powerpoint/2015/10/main">
   <p1510:revLst>
-    <p1510:client id="{F358A31B-DE9E-6949-8979-A99DE7F59D8D}" v="107" dt="2026-07-17T06:39:54.871"/>
+    <p1510:client id="{0057D6CD-22DF-9A4D-B38A-0D0CFC8CB9A8}" v="1" dt="2026-07-17T07:35:12.509"/>
   </p1510:revLst>
 </p1510:revInfo>
-</file>
-
-<file path=ppt/changesInfos/changesInfo1.xml><?xml version="1.0" encoding="utf-8"?>
-<pc:chgInfo xmlns:a="http://schemas.openxmlformats.org/drawingml/2006/main" xmlns:r="http://schemas.openxmlformats.org/officeDocument/2006/relationships" xmlns:ac="http://schemas.microsoft.com/office/drawing/2013/main/command" xmlns:pc="http://schemas.microsoft.com/office/powerpoint/2013/main/command">
-  <pc:docChgLst>
-    <pc:chgData name="Allan, John" userId="e8ef1c47-ed91-448d-adaf-3df63196cc6d" providerId="ADAL" clId="{954915EC-4E4C-5938-BB5E-75752EC955AC}"/>
-    <pc:docChg chg="undo custSel addSld delSld modSld sldOrd">
-      <pc:chgData name="Allan, John" userId="e8ef1c47-ed91-448d-adaf-3df63196cc6d" providerId="ADAL" clId="{954915EC-4E4C-5938-BB5E-75752EC955AC}" dt="2026-07-17T06:42:01.827" v="650" actId="207"/>
-      <pc:docMkLst>
-        <pc:docMk/>
-      </pc:docMkLst>
-      <pc:sldChg chg="modSp mod">
-        <pc:chgData name="Allan, John" userId="e8ef1c47-ed91-448d-adaf-3df63196cc6d" providerId="ADAL" clId="{954915EC-4E4C-5938-BB5E-75752EC955AC}" dt="2026-07-17T06:13:11.682" v="528" actId="13244"/>
-        <pc:sldMkLst>
-          <pc:docMk/>
-          <pc:sldMk cId="0" sldId="256"/>
-        </pc:sldMkLst>
-        <pc:spChg chg="ord">
-          <ac:chgData name="Allan, John" userId="e8ef1c47-ed91-448d-adaf-3df63196cc6d" providerId="ADAL" clId="{954915EC-4E4C-5938-BB5E-75752EC955AC}" dt="2026-07-17T04:03:09.402" v="4"/>
-          <ac:spMkLst>
-            <pc:docMk/>
-            <pc:sldMk cId="0" sldId="256"/>
-            <ac:spMk id="2" creationId="{00000000-0000-0000-0000-000000000000}"/>
-          </ac:spMkLst>
-        </pc:spChg>
-        <pc:spChg chg="ord">
-          <ac:chgData name="Allan, John" userId="e8ef1c47-ed91-448d-adaf-3df63196cc6d" providerId="ADAL" clId="{954915EC-4E4C-5938-BB5E-75752EC955AC}" dt="2026-07-17T04:03:09.402" v="4"/>
-          <ac:spMkLst>
-            <pc:docMk/>
-            <pc:sldMk cId="0" sldId="256"/>
-            <ac:spMk id="4" creationId="{00000000-0000-0000-0000-000000000000}"/>
-          </ac:spMkLst>
-        </pc:spChg>
-        <pc:spChg chg="mod">
-          <ac:chgData name="Allan, John" userId="e8ef1c47-ed91-448d-adaf-3df63196cc6d" providerId="ADAL" clId="{954915EC-4E4C-5938-BB5E-75752EC955AC}" dt="2026-07-17T04:03:20.793" v="5" actId="13244"/>
-          <ac:spMkLst>
-            <pc:docMk/>
-            <pc:sldMk cId="0" sldId="256"/>
-            <ac:spMk id="5" creationId="{00000000-0000-0000-0000-000000000000}"/>
-          </ac:spMkLst>
-        </pc:spChg>
-        <pc:spChg chg="mod ord">
-          <ac:chgData name="Allan, John" userId="e8ef1c47-ed91-448d-adaf-3df63196cc6d" providerId="ADAL" clId="{954915EC-4E4C-5938-BB5E-75752EC955AC}" dt="2026-07-17T06:13:11.682" v="528" actId="13244"/>
-          <ac:spMkLst>
-            <pc:docMk/>
-            <pc:sldMk cId="0" sldId="256"/>
-            <ac:spMk id="6" creationId="{00000000-0000-0000-0000-000000000000}"/>
-          </ac:spMkLst>
-        </pc:spChg>
-        <pc:spChg chg="mod">
-          <ac:chgData name="Allan, John" userId="e8ef1c47-ed91-448d-adaf-3df63196cc6d" providerId="ADAL" clId="{954915EC-4E4C-5938-BB5E-75752EC955AC}" dt="2026-07-17T04:03:27.999" v="7" actId="13244"/>
-          <ac:spMkLst>
-            <pc:docMk/>
-            <pc:sldMk cId="0" sldId="256"/>
-            <ac:spMk id="7" creationId="{00000000-0000-0000-0000-000000000000}"/>
-          </ac:spMkLst>
-        </pc:spChg>
-        <pc:spChg chg="ord">
-          <ac:chgData name="Allan, John" userId="e8ef1c47-ed91-448d-adaf-3df63196cc6d" providerId="ADAL" clId="{954915EC-4E4C-5938-BB5E-75752EC955AC}" dt="2026-07-17T04:03:09.402" v="4"/>
-          <ac:spMkLst>
-            <pc:docMk/>
-            <pc:sldMk cId="0" sldId="256"/>
-            <ac:spMk id="8" creationId="{00000000-0000-0000-0000-000000000000}"/>
-          </ac:spMkLst>
-        </pc:spChg>
-        <pc:spChg chg="ord">
-          <ac:chgData name="Allan, John" userId="e8ef1c47-ed91-448d-adaf-3df63196cc6d" providerId="ADAL" clId="{954915EC-4E4C-5938-BB5E-75752EC955AC}" dt="2026-07-17T04:03:09.402" v="4"/>
-          <ac:spMkLst>
-            <pc:docMk/>
-            <pc:sldMk cId="0" sldId="256"/>
-            <ac:spMk id="10" creationId="{00000000-0000-0000-0000-000000000000}"/>
-          </ac:spMkLst>
-        </pc:spChg>
-        <pc:spChg chg="ord">
-          <ac:chgData name="Allan, John" userId="e8ef1c47-ed91-448d-adaf-3df63196cc6d" providerId="ADAL" clId="{954915EC-4E4C-5938-BB5E-75752EC955AC}" dt="2026-07-17T04:03:09.402" v="4"/>
-          <ac:spMkLst>
-            <pc:docMk/>
-            <pc:sldMk cId="0" sldId="256"/>
-            <ac:spMk id="11" creationId="{00000000-0000-0000-0000-000000000000}"/>
-          </ac:spMkLst>
-        </pc:spChg>
-        <pc:spChg chg="ord">
-          <ac:chgData name="Allan, John" userId="e8ef1c47-ed91-448d-adaf-3df63196cc6d" providerId="ADAL" clId="{954915EC-4E4C-5938-BB5E-75752EC955AC}" dt="2026-07-17T04:03:09.402" v="4"/>
-          <ac:spMkLst>
-            <pc:docMk/>
-            <pc:sldMk cId="0" sldId="256"/>
-            <ac:spMk id="12" creationId="{00000000-0000-0000-0000-000000000000}"/>
-          </ac:spMkLst>
-        </pc:spChg>
-        <pc:spChg chg="ord">
-          <ac:chgData name="Allan, John" userId="e8ef1c47-ed91-448d-adaf-3df63196cc6d" providerId="ADAL" clId="{954915EC-4E4C-5938-BB5E-75752EC955AC}" dt="2026-07-17T04:03:09.402" v="4"/>
-          <ac:spMkLst>
-            <pc:docMk/>
-            <pc:sldMk cId="0" sldId="256"/>
-            <ac:spMk id="14" creationId="{00000000-0000-0000-0000-000000000000}"/>
-          </ac:spMkLst>
-        </pc:spChg>
-        <pc:spChg chg="ord">
-          <ac:chgData name="Allan, John" userId="e8ef1c47-ed91-448d-adaf-3df63196cc6d" providerId="ADAL" clId="{954915EC-4E4C-5938-BB5E-75752EC955AC}" dt="2026-07-17T04:03:09.402" v="4"/>
-          <ac:spMkLst>
-            <pc:docMk/>
-            <pc:sldMk cId="0" sldId="256"/>
-            <ac:spMk id="15" creationId="{00000000-0000-0000-0000-000000000000}"/>
-          </ac:spMkLst>
-        </pc:spChg>
-        <pc:spChg chg="ord">
-          <ac:chgData name="Allan, John" userId="e8ef1c47-ed91-448d-adaf-3df63196cc6d" providerId="ADAL" clId="{954915EC-4E4C-5938-BB5E-75752EC955AC}" dt="2026-07-17T04:03:09.402" v="4"/>
-          <ac:spMkLst>
-            <pc:docMk/>
-            <pc:sldMk cId="0" sldId="256"/>
-            <ac:spMk id="16" creationId="{00000000-0000-0000-0000-000000000000}"/>
-          </ac:spMkLst>
-        </pc:spChg>
-        <pc:spChg chg="ord">
-          <ac:chgData name="Allan, John" userId="e8ef1c47-ed91-448d-adaf-3df63196cc6d" providerId="ADAL" clId="{954915EC-4E4C-5938-BB5E-75752EC955AC}" dt="2026-07-17T04:03:09.402" v="4"/>
-          <ac:spMkLst>
-            <pc:docMk/>
-            <pc:sldMk cId="0" sldId="256"/>
-            <ac:spMk id="17" creationId="{00000000-0000-0000-0000-000000000000}"/>
-          </ac:spMkLst>
-        </pc:spChg>
-      </pc:sldChg>
-      <pc:sldChg chg="addSp delSp modSp mod">
-        <pc:chgData name="Allan, John" userId="e8ef1c47-ed91-448d-adaf-3df63196cc6d" providerId="ADAL" clId="{954915EC-4E4C-5938-BB5E-75752EC955AC}" dt="2026-07-17T06:18:31.293" v="561" actId="13244"/>
-        <pc:sldMkLst>
-          <pc:docMk/>
-          <pc:sldMk cId="0" sldId="257"/>
-        </pc:sldMkLst>
-        <pc:spChg chg="ord">
-          <ac:chgData name="Allan, John" userId="e8ef1c47-ed91-448d-adaf-3df63196cc6d" providerId="ADAL" clId="{954915EC-4E4C-5938-BB5E-75752EC955AC}" dt="2026-07-17T06:17:56.212" v="559"/>
-          <ac:spMkLst>
-            <pc:docMk/>
-            <pc:sldMk cId="0" sldId="257"/>
-            <ac:spMk id="2" creationId="{00000000-0000-0000-0000-000000000000}"/>
-          </ac:spMkLst>
-        </pc:spChg>
-        <pc:spChg chg="add del">
-          <ac:chgData name="Allan, John" userId="e8ef1c47-ed91-448d-adaf-3df63196cc6d" providerId="ADAL" clId="{954915EC-4E4C-5938-BB5E-75752EC955AC}" dt="2026-07-17T04:48:28.943" v="72" actId="478"/>
-          <ac:spMkLst>
-            <pc:docMk/>
-            <pc:sldMk cId="0" sldId="257"/>
-            <ac:spMk id="3" creationId="{00000000-0000-0000-0000-000000000000}"/>
-          </ac:spMkLst>
-        </pc:spChg>
-        <pc:spChg chg="add mod ord">
-          <ac:chgData name="Allan, John" userId="e8ef1c47-ed91-448d-adaf-3df63196cc6d" providerId="ADAL" clId="{954915EC-4E4C-5938-BB5E-75752EC955AC}" dt="2026-07-17T06:17:45.932" v="558" actId="13244"/>
-          <ac:spMkLst>
-            <pc:docMk/>
-            <pc:sldMk cId="0" sldId="257"/>
-            <ac:spMk id="3" creationId="{C8CA44BE-6F63-F897-E8C7-E39218C12CAA}"/>
-          </ac:spMkLst>
-        </pc:spChg>
-        <pc:spChg chg="del mod">
-          <ac:chgData name="Allan, John" userId="e8ef1c47-ed91-448d-adaf-3df63196cc6d" providerId="ADAL" clId="{954915EC-4E4C-5938-BB5E-75752EC955AC}" dt="2026-07-17T04:48:41.138" v="74" actId="478"/>
-          <ac:spMkLst>
-            <pc:docMk/>
-            <pc:sldMk cId="0" sldId="257"/>
-            <ac:spMk id="4" creationId="{00000000-0000-0000-0000-000000000000}"/>
-          </ac:spMkLst>
-        </pc:spChg>
-        <pc:spChg chg="add mod ord">
-          <ac:chgData name="Allan, John" userId="e8ef1c47-ed91-448d-adaf-3df63196cc6d" providerId="ADAL" clId="{954915EC-4E4C-5938-BB5E-75752EC955AC}" dt="2026-07-17T06:17:56.212" v="559"/>
-          <ac:spMkLst>
-            <pc:docMk/>
-            <pc:sldMk cId="0" sldId="257"/>
-            <ac:spMk id="4" creationId="{329BB93F-6C43-C5A8-5DE8-5612283513A1}"/>
-          </ac:spMkLst>
-        </pc:spChg>
-        <pc:spChg chg="mod ord">
-          <ac:chgData name="Allan, John" userId="e8ef1c47-ed91-448d-adaf-3df63196cc6d" providerId="ADAL" clId="{954915EC-4E4C-5938-BB5E-75752EC955AC}" dt="2026-07-17T06:17:56.212" v="559"/>
-          <ac:spMkLst>
-            <pc:docMk/>
-            <pc:sldMk cId="0" sldId="257"/>
-            <ac:spMk id="5" creationId="{00000000-0000-0000-0000-000000000000}"/>
-          </ac:spMkLst>
-        </pc:spChg>
-        <pc:spChg chg="ord">
-          <ac:chgData name="Allan, John" userId="e8ef1c47-ed91-448d-adaf-3df63196cc6d" providerId="ADAL" clId="{954915EC-4E4C-5938-BB5E-75752EC955AC}" dt="2026-07-17T06:17:33.184" v="557" actId="13244"/>
-          <ac:spMkLst>
-            <pc:docMk/>
-            <pc:sldMk cId="0" sldId="257"/>
-            <ac:spMk id="6" creationId="{00000000-0000-0000-0000-000000000000}"/>
-          </ac:spMkLst>
-        </pc:spChg>
-        <pc:spChg chg="mod ord">
-          <ac:chgData name="Allan, John" userId="e8ef1c47-ed91-448d-adaf-3df63196cc6d" providerId="ADAL" clId="{954915EC-4E4C-5938-BB5E-75752EC955AC}" dt="2026-07-17T06:18:18.042" v="560" actId="13244"/>
-          <ac:spMkLst>
-            <pc:docMk/>
-            <pc:sldMk cId="0" sldId="257"/>
-            <ac:spMk id="7" creationId="{00000000-0000-0000-0000-000000000000}"/>
-          </ac:spMkLst>
-        </pc:spChg>
-        <pc:spChg chg="ord">
-          <ac:chgData name="Allan, John" userId="e8ef1c47-ed91-448d-adaf-3df63196cc6d" providerId="ADAL" clId="{954915EC-4E4C-5938-BB5E-75752EC955AC}" dt="2026-07-17T06:17:56.212" v="559"/>
-          <ac:spMkLst>
-            <pc:docMk/>
-            <pc:sldMk cId="0" sldId="257"/>
-            <ac:spMk id="11" creationId="{00000000-0000-0000-0000-000000000000}"/>
-          </ac:spMkLst>
-        </pc:spChg>
-        <pc:spChg chg="ord">
-          <ac:chgData name="Allan, John" userId="e8ef1c47-ed91-448d-adaf-3df63196cc6d" providerId="ADAL" clId="{954915EC-4E4C-5938-BB5E-75752EC955AC}" dt="2026-07-17T06:17:56.212" v="559"/>
-          <ac:spMkLst>
-            <pc:docMk/>
-            <pc:sldMk cId="0" sldId="257"/>
-            <ac:spMk id="14" creationId="{00000000-0000-0000-0000-000000000000}"/>
-          </ac:spMkLst>
-        </pc:spChg>
-        <pc:spChg chg="ord">
-          <ac:chgData name="Allan, John" userId="e8ef1c47-ed91-448d-adaf-3df63196cc6d" providerId="ADAL" clId="{954915EC-4E4C-5938-BB5E-75752EC955AC}" dt="2026-07-17T06:17:56.212" v="559"/>
-          <ac:spMkLst>
-            <pc:docMk/>
-            <pc:sldMk cId="0" sldId="257"/>
-            <ac:spMk id="16" creationId="{00000000-0000-0000-0000-000000000000}"/>
-          </ac:spMkLst>
-        </pc:spChg>
-        <pc:spChg chg="ord">
-          <ac:chgData name="Allan, John" userId="e8ef1c47-ed91-448d-adaf-3df63196cc6d" providerId="ADAL" clId="{954915EC-4E4C-5938-BB5E-75752EC955AC}" dt="2026-07-17T06:17:56.212" v="559"/>
-          <ac:spMkLst>
-            <pc:docMk/>
-            <pc:sldMk cId="0" sldId="257"/>
-            <ac:spMk id="18" creationId="{00000000-0000-0000-0000-000000000000}"/>
-          </ac:spMkLst>
-        </pc:spChg>
-        <pc:spChg chg="ord">
-          <ac:chgData name="Allan, John" userId="e8ef1c47-ed91-448d-adaf-3df63196cc6d" providerId="ADAL" clId="{954915EC-4E4C-5938-BB5E-75752EC955AC}" dt="2026-07-17T06:17:56.212" v="559"/>
-          <ac:spMkLst>
-            <pc:docMk/>
-            <pc:sldMk cId="0" sldId="257"/>
-            <ac:spMk id="19" creationId="{00000000-0000-0000-0000-000000000000}"/>
-          </ac:spMkLst>
-        </pc:spChg>
-        <pc:spChg chg="ord">
-          <ac:chgData name="Allan, John" userId="e8ef1c47-ed91-448d-adaf-3df63196cc6d" providerId="ADAL" clId="{954915EC-4E4C-5938-BB5E-75752EC955AC}" dt="2026-07-17T06:17:56.212" v="559"/>
-          <ac:spMkLst>
-            <pc:docMk/>
-            <pc:sldMk cId="0" sldId="257"/>
-            <ac:spMk id="20" creationId="{00000000-0000-0000-0000-000000000000}"/>
-          </ac:spMkLst>
-        </pc:spChg>
-        <pc:spChg chg="ord">
-          <ac:chgData name="Allan, John" userId="e8ef1c47-ed91-448d-adaf-3df63196cc6d" providerId="ADAL" clId="{954915EC-4E4C-5938-BB5E-75752EC955AC}" dt="2026-07-17T06:17:56.212" v="559"/>
-          <ac:spMkLst>
-            <pc:docMk/>
-            <pc:sldMk cId="0" sldId="257"/>
-            <ac:spMk id="21" creationId="{00000000-0000-0000-0000-000000000000}"/>
-          </ac:spMkLst>
-        </pc:spChg>
-        <pc:spChg chg="ord">
-          <ac:chgData name="Allan, John" userId="e8ef1c47-ed91-448d-adaf-3df63196cc6d" providerId="ADAL" clId="{954915EC-4E4C-5938-BB5E-75752EC955AC}" dt="2026-07-17T06:18:31.293" v="561" actId="13244"/>
-          <ac:spMkLst>
-            <pc:docMk/>
-            <pc:sldMk cId="0" sldId="257"/>
-            <ac:spMk id="25" creationId="{00000000-0000-0000-0000-000000000000}"/>
-          </ac:spMkLst>
-        </pc:spChg>
-        <pc:spChg chg="add del mod">
-          <ac:chgData name="Allan, John" userId="e8ef1c47-ed91-448d-adaf-3df63196cc6d" providerId="ADAL" clId="{954915EC-4E4C-5938-BB5E-75752EC955AC}" dt="2026-07-17T04:49:20.034" v="80" actId="21"/>
-          <ac:spMkLst>
-            <pc:docMk/>
-            <pc:sldMk cId="0" sldId="257"/>
-            <ac:spMk id="26" creationId="{C3C9EBB8-FF47-DB27-8C9E-3118DF77EE69}"/>
-          </ac:spMkLst>
-        </pc:spChg>
-        <pc:spChg chg="add del mod">
-          <ac:chgData name="Allan, John" userId="e8ef1c47-ed91-448d-adaf-3df63196cc6d" providerId="ADAL" clId="{954915EC-4E4C-5938-BB5E-75752EC955AC}" dt="2026-07-17T05:49:34.617" v="236" actId="478"/>
-          <ac:spMkLst>
-            <pc:docMk/>
-            <pc:sldMk cId="0" sldId="257"/>
-            <ac:spMk id="27" creationId="{6A82F540-CAC1-D809-DD58-86142B39D45A}"/>
-          </ac:spMkLst>
-        </pc:spChg>
-        <pc:spChg chg="add del mod">
-          <ac:chgData name="Allan, John" userId="e8ef1c47-ed91-448d-adaf-3df63196cc6d" providerId="ADAL" clId="{954915EC-4E4C-5938-BB5E-75752EC955AC}" dt="2026-07-17T05:49:33.898" v="235" actId="478"/>
-          <ac:spMkLst>
-            <pc:docMk/>
-            <pc:sldMk cId="0" sldId="257"/>
-            <ac:spMk id="28" creationId="{7969469C-1EBB-6DB3-4725-EB19A2A9D104}"/>
-          </ac:spMkLst>
-        </pc:spChg>
-      </pc:sldChg>
-      <pc:sldChg chg="addSp delSp modSp mod ord">
-        <pc:chgData name="Allan, John" userId="e8ef1c47-ed91-448d-adaf-3df63196cc6d" providerId="ADAL" clId="{954915EC-4E4C-5938-BB5E-75752EC955AC}" dt="2026-07-17T06:16:41.429" v="548" actId="13244"/>
-        <pc:sldMkLst>
-          <pc:docMk/>
-          <pc:sldMk cId="0" sldId="258"/>
-        </pc:sldMkLst>
-        <pc:spChg chg="mod ord">
-          <ac:chgData name="Allan, John" userId="e8ef1c47-ed91-448d-adaf-3df63196cc6d" providerId="ADAL" clId="{954915EC-4E4C-5938-BB5E-75752EC955AC}" dt="2026-07-17T06:16:27.547" v="547"/>
-          <ac:spMkLst>
-            <pc:docMk/>
-            <pc:sldMk cId="0" sldId="258"/>
-            <ac:spMk id="2" creationId="{00000000-0000-0000-0000-000000000000}"/>
-          </ac:spMkLst>
-        </pc:spChg>
-        <pc:spChg chg="del">
-          <ac:chgData name="Allan, John" userId="e8ef1c47-ed91-448d-adaf-3df63196cc6d" providerId="ADAL" clId="{954915EC-4E4C-5938-BB5E-75752EC955AC}" dt="2026-07-17T05:49:14.198" v="229" actId="478"/>
-          <ac:spMkLst>
-            <pc:docMk/>
-            <pc:sldMk cId="0" sldId="258"/>
-            <ac:spMk id="3" creationId="{00000000-0000-0000-0000-000000000000}"/>
-          </ac:spMkLst>
-        </pc:spChg>
-        <pc:spChg chg="del">
-          <ac:chgData name="Allan, John" userId="e8ef1c47-ed91-448d-adaf-3df63196cc6d" providerId="ADAL" clId="{954915EC-4E4C-5938-BB5E-75752EC955AC}" dt="2026-07-17T05:49:16.740" v="230" actId="478"/>
-          <ac:spMkLst>
-            <pc:docMk/>
-            <pc:sldMk cId="0" sldId="258"/>
-            <ac:spMk id="4" creationId="{00000000-0000-0000-0000-000000000000}"/>
-          </ac:spMkLst>
-        </pc:spChg>
-        <pc:spChg chg="mod ord">
-          <ac:chgData name="Allan, John" userId="e8ef1c47-ed91-448d-adaf-3df63196cc6d" providerId="ADAL" clId="{954915EC-4E4C-5938-BB5E-75752EC955AC}" dt="2026-07-17T06:16:27.547" v="547"/>
-          <ac:spMkLst>
-            <pc:docMk/>
-            <pc:sldMk cId="0" sldId="258"/>
-            <ac:spMk id="5" creationId="{00000000-0000-0000-0000-000000000000}"/>
-          </ac:spMkLst>
-        </pc:spChg>
-        <pc:spChg chg="mod ord">
-          <ac:chgData name="Allan, John" userId="e8ef1c47-ed91-448d-adaf-3df63196cc6d" providerId="ADAL" clId="{954915EC-4E4C-5938-BB5E-75752EC955AC}" dt="2026-07-17T06:16:27.547" v="547"/>
-          <ac:spMkLst>
-            <pc:docMk/>
-            <pc:sldMk cId="0" sldId="258"/>
-            <ac:spMk id="6" creationId="{00000000-0000-0000-0000-000000000000}"/>
-          </ac:spMkLst>
-        </pc:spChg>
-        <pc:spChg chg="ord">
-          <ac:chgData name="Allan, John" userId="e8ef1c47-ed91-448d-adaf-3df63196cc6d" providerId="ADAL" clId="{954915EC-4E4C-5938-BB5E-75752EC955AC}" dt="2026-07-17T06:16:41.429" v="548" actId="13244"/>
-          <ac:spMkLst>
-            <pc:docMk/>
-            <pc:sldMk cId="0" sldId="258"/>
-            <ac:spMk id="7" creationId="{00000000-0000-0000-0000-000000000000}"/>
-          </ac:spMkLst>
-        </pc:spChg>
-        <pc:spChg chg="ord">
-          <ac:chgData name="Allan, John" userId="e8ef1c47-ed91-448d-adaf-3df63196cc6d" providerId="ADAL" clId="{954915EC-4E4C-5938-BB5E-75752EC955AC}" dt="2026-07-17T06:16:27.547" v="547"/>
-          <ac:spMkLst>
-            <pc:docMk/>
-            <pc:sldMk cId="0" sldId="258"/>
-            <ac:spMk id="8" creationId="{00000000-0000-0000-0000-000000000000}"/>
-          </ac:spMkLst>
-        </pc:spChg>
-        <pc:spChg chg="add del">
-          <ac:chgData name="Allan, John" userId="e8ef1c47-ed91-448d-adaf-3df63196cc6d" providerId="ADAL" clId="{954915EC-4E4C-5938-BB5E-75752EC955AC}" dt="2026-07-17T04:07:25.068" v="44" actId="21"/>
-          <ac:spMkLst>
-            <pc:docMk/>
-            <pc:sldMk cId="0" sldId="258"/>
-            <ac:spMk id="9" creationId="{00000000-0000-0000-0000-000000000000}"/>
-          </ac:spMkLst>
-        </pc:spChg>
-        <pc:spChg chg="add mod ord">
-          <ac:chgData name="Allan, John" userId="e8ef1c47-ed91-448d-adaf-3df63196cc6d" providerId="ADAL" clId="{954915EC-4E4C-5938-BB5E-75752EC955AC}" dt="2026-07-17T06:16:27.547" v="547"/>
-          <ac:spMkLst>
-            <pc:docMk/>
-            <pc:sldMk cId="0" sldId="258"/>
-            <ac:spMk id="9" creationId="{C96678AB-1932-8EF5-E14F-9351353744D5}"/>
-          </ac:spMkLst>
-        </pc:spChg>
-        <pc:spChg chg="add del">
-          <ac:chgData name="Allan, John" userId="e8ef1c47-ed91-448d-adaf-3df63196cc6d" providerId="ADAL" clId="{954915EC-4E4C-5938-BB5E-75752EC955AC}" dt="2026-07-17T04:07:25.068" v="44" actId="21"/>
-          <ac:spMkLst>
-            <pc:docMk/>
-            <pc:sldMk cId="0" sldId="258"/>
-            <ac:spMk id="10" creationId="{00000000-0000-0000-0000-000000000000}"/>
-          </ac:spMkLst>
-        </pc:spChg>
-        <pc:spChg chg="add mod ord">
-          <ac:chgData name="Allan, John" userId="e8ef1c47-ed91-448d-adaf-3df63196cc6d" providerId="ADAL" clId="{954915EC-4E4C-5938-BB5E-75752EC955AC}" dt="2026-07-17T06:16:27.547" v="547"/>
-          <ac:spMkLst>
-            <pc:docMk/>
-            <pc:sldMk cId="0" sldId="258"/>
-            <ac:spMk id="10" creationId="{F5ABCA3A-4BC4-160F-B0C6-EDEC2339A6D3}"/>
-          </ac:spMkLst>
-        </pc:spChg>
-        <pc:spChg chg="add del">
-          <ac:chgData name="Allan, John" userId="e8ef1c47-ed91-448d-adaf-3df63196cc6d" providerId="ADAL" clId="{954915EC-4E4C-5938-BB5E-75752EC955AC}" dt="2026-07-17T04:07:25.068" v="44" actId="21"/>
-          <ac:spMkLst>
-            <pc:docMk/>
-            <pc:sldMk cId="0" sldId="258"/>
-            <ac:spMk id="11" creationId="{00000000-0000-0000-0000-000000000000}"/>
-          </ac:spMkLst>
-        </pc:spChg>
-        <pc:spChg chg="add del">
-          <ac:chgData name="Allan, John" userId="e8ef1c47-ed91-448d-adaf-3df63196cc6d" providerId="ADAL" clId="{954915EC-4E4C-5938-BB5E-75752EC955AC}" dt="2026-07-17T04:07:25.068" v="44" actId="21"/>
-          <ac:spMkLst>
-            <pc:docMk/>
-            <pc:sldMk cId="0" sldId="258"/>
-            <ac:spMk id="12" creationId="{00000000-0000-0000-0000-000000000000}"/>
-          </ac:spMkLst>
-        </pc:spChg>
-        <pc:spChg chg="ord">
-          <ac:chgData name="Allan, John" userId="e8ef1c47-ed91-448d-adaf-3df63196cc6d" providerId="ADAL" clId="{954915EC-4E4C-5938-BB5E-75752EC955AC}" dt="2026-07-17T06:16:27.547" v="547"/>
-          <ac:spMkLst>
-            <pc:docMk/>
-            <pc:sldMk cId="0" sldId="258"/>
-            <ac:spMk id="13" creationId="{00000000-0000-0000-0000-000000000000}"/>
-          </ac:spMkLst>
-        </pc:spChg>
-        <pc:spChg chg="add del">
-          <ac:chgData name="Allan, John" userId="e8ef1c47-ed91-448d-adaf-3df63196cc6d" providerId="ADAL" clId="{954915EC-4E4C-5938-BB5E-75752EC955AC}" dt="2026-07-17T04:07:25.068" v="44" actId="21"/>
-          <ac:spMkLst>
-            <pc:docMk/>
-            <pc:sldMk cId="0" sldId="258"/>
-            <ac:spMk id="14" creationId="{00000000-0000-0000-0000-000000000000}"/>
-          </ac:spMkLst>
-        </pc:spChg>
-        <pc:spChg chg="add del">
-          <ac:chgData name="Allan, John" userId="e8ef1c47-ed91-448d-adaf-3df63196cc6d" providerId="ADAL" clId="{954915EC-4E4C-5938-BB5E-75752EC955AC}" dt="2026-07-17T04:07:25.068" v="44" actId="21"/>
-          <ac:spMkLst>
-            <pc:docMk/>
-            <pc:sldMk cId="0" sldId="258"/>
-            <ac:spMk id="15" creationId="{00000000-0000-0000-0000-000000000000}"/>
-          </ac:spMkLst>
-        </pc:spChg>
-        <pc:spChg chg="add del">
-          <ac:chgData name="Allan, John" userId="e8ef1c47-ed91-448d-adaf-3df63196cc6d" providerId="ADAL" clId="{954915EC-4E4C-5938-BB5E-75752EC955AC}" dt="2026-07-17T04:07:25.068" v="44" actId="21"/>
-          <ac:spMkLst>
-            <pc:docMk/>
-            <pc:sldMk cId="0" sldId="258"/>
-            <ac:spMk id="16" creationId="{00000000-0000-0000-0000-000000000000}"/>
-          </ac:spMkLst>
-        </pc:spChg>
-        <pc:spChg chg="add del">
-          <ac:chgData name="Allan, John" userId="e8ef1c47-ed91-448d-adaf-3df63196cc6d" providerId="ADAL" clId="{954915EC-4E4C-5938-BB5E-75752EC955AC}" dt="2026-07-17T04:07:25.068" v="44" actId="21"/>
-          <ac:spMkLst>
-            <pc:docMk/>
-            <pc:sldMk cId="0" sldId="258"/>
-            <ac:spMk id="17" creationId="{00000000-0000-0000-0000-000000000000}"/>
-          </ac:spMkLst>
-        </pc:spChg>
-        <pc:spChg chg="add del mod">
-          <ac:chgData name="Allan, John" userId="e8ef1c47-ed91-448d-adaf-3df63196cc6d" providerId="ADAL" clId="{954915EC-4E4C-5938-BB5E-75752EC955AC}" dt="2026-07-17T04:51:24.732" v="93" actId="21"/>
-          <ac:spMkLst>
-            <pc:docMk/>
-            <pc:sldMk cId="0" sldId="258"/>
-            <ac:spMk id="18" creationId="{00000000-0000-0000-0000-000000000000}"/>
-          </ac:spMkLst>
-        </pc:spChg>
-        <pc:spChg chg="add del mod">
-          <ac:chgData name="Allan, John" userId="e8ef1c47-ed91-448d-adaf-3df63196cc6d" providerId="ADAL" clId="{954915EC-4E4C-5938-BB5E-75752EC955AC}" dt="2026-07-17T04:51:23.502" v="92" actId="21"/>
-          <ac:spMkLst>
-            <pc:docMk/>
-            <pc:sldMk cId="0" sldId="258"/>
-            <ac:spMk id="19" creationId="{00000000-0000-0000-0000-000000000000}"/>
-          </ac:spMkLst>
-        </pc:spChg>
-        <pc:spChg chg="add del">
-          <ac:chgData name="Allan, John" userId="e8ef1c47-ed91-448d-adaf-3df63196cc6d" providerId="ADAL" clId="{954915EC-4E4C-5938-BB5E-75752EC955AC}" dt="2026-07-17T04:51:26.202" v="94" actId="21"/>
-          <ac:spMkLst>
-            <pc:docMk/>
-            <pc:sldMk cId="0" sldId="258"/>
-            <ac:spMk id="20" creationId="{00000000-0000-0000-0000-000000000000}"/>
-          </ac:spMkLst>
-        </pc:spChg>
-        <pc:spChg chg="del mod">
-          <ac:chgData name="Allan, John" userId="e8ef1c47-ed91-448d-adaf-3df63196cc6d" providerId="ADAL" clId="{954915EC-4E4C-5938-BB5E-75752EC955AC}" dt="2026-07-17T04:51:28.503" v="95" actId="21"/>
-          <ac:spMkLst>
-            <pc:docMk/>
-            <pc:sldMk cId="0" sldId="258"/>
-            <ac:spMk id="21" creationId="{00000000-0000-0000-0000-000000000000}"/>
-          </ac:spMkLst>
-        </pc:spChg>
-        <pc:spChg chg="ord">
-          <ac:chgData name="Allan, John" userId="e8ef1c47-ed91-448d-adaf-3df63196cc6d" providerId="ADAL" clId="{954915EC-4E4C-5938-BB5E-75752EC955AC}" dt="2026-07-17T06:16:27.547" v="547"/>
-          <ac:spMkLst>
-            <pc:docMk/>
-            <pc:sldMk cId="0" sldId="258"/>
-            <ac:spMk id="22" creationId="{00000000-0000-0000-0000-000000000000}"/>
-          </ac:spMkLst>
-        </pc:spChg>
-        <pc:picChg chg="add mod ord">
-          <ac:chgData name="Allan, John" userId="e8ef1c47-ed91-448d-adaf-3df63196cc6d" providerId="ADAL" clId="{954915EC-4E4C-5938-BB5E-75752EC955AC}" dt="2026-07-17T06:16:27.547" v="547"/>
-          <ac:picMkLst>
-            <pc:docMk/>
-            <pc:sldMk cId="0" sldId="258"/>
-            <ac:picMk id="23" creationId="{A872B511-087D-0D46-D813-7BBAA0903662}"/>
-          </ac:picMkLst>
-        </pc:picChg>
-        <pc:picChg chg="add mod modCrop">
-          <ac:chgData name="Allan, John" userId="e8ef1c47-ed91-448d-adaf-3df63196cc6d" providerId="ADAL" clId="{954915EC-4E4C-5938-BB5E-75752EC955AC}" dt="2026-07-17T06:12:23.803" v="517" actId="962"/>
-          <ac:picMkLst>
-            <pc:docMk/>
-            <pc:sldMk cId="0" sldId="258"/>
-            <ac:picMk id="24" creationId="{3C1DE61F-E344-7A18-C0FB-2146BDC18605}"/>
-          </ac:picMkLst>
-        </pc:picChg>
-      </pc:sldChg>
-      <pc:sldChg chg="del">
-        <pc:chgData name="Allan, John" userId="e8ef1c47-ed91-448d-adaf-3df63196cc6d" providerId="ADAL" clId="{954915EC-4E4C-5938-BB5E-75752EC955AC}" dt="2026-07-17T05:38:15.829" v="197" actId="2696"/>
-        <pc:sldMkLst>
-          <pc:docMk/>
-          <pc:sldMk cId="0" sldId="259"/>
-        </pc:sldMkLst>
-      </pc:sldChg>
-      <pc:sldChg chg="addSp delSp modSp mod ord">
-        <pc:chgData name="Allan, John" userId="e8ef1c47-ed91-448d-adaf-3df63196cc6d" providerId="ADAL" clId="{954915EC-4E4C-5938-BB5E-75752EC955AC}" dt="2026-07-17T06:17:16.572" v="553" actId="13244"/>
-        <pc:sldMkLst>
-          <pc:docMk/>
-          <pc:sldMk cId="0" sldId="260"/>
-        </pc:sldMkLst>
-        <pc:spChg chg="del">
-          <ac:chgData name="Allan, John" userId="e8ef1c47-ed91-448d-adaf-3df63196cc6d" providerId="ADAL" clId="{954915EC-4E4C-5938-BB5E-75752EC955AC}" dt="2026-07-17T05:49:22.051" v="232" actId="478"/>
-          <ac:spMkLst>
-            <pc:docMk/>
-            <pc:sldMk cId="0" sldId="260"/>
-            <ac:spMk id="3" creationId="{00000000-0000-0000-0000-000000000000}"/>
-          </ac:spMkLst>
-        </pc:spChg>
-        <pc:spChg chg="del">
-          <ac:chgData name="Allan, John" userId="e8ef1c47-ed91-448d-adaf-3df63196cc6d" providerId="ADAL" clId="{954915EC-4E4C-5938-BB5E-75752EC955AC}" dt="2026-07-17T05:49:24.107" v="233" actId="478"/>
-          <ac:spMkLst>
-            <pc:docMk/>
-            <pc:sldMk cId="0" sldId="260"/>
-            <ac:spMk id="4" creationId="{00000000-0000-0000-0000-000000000000}"/>
-          </ac:spMkLst>
-        </pc:spChg>
-        <pc:spChg chg="ord">
-          <ac:chgData name="Allan, John" userId="e8ef1c47-ed91-448d-adaf-3df63196cc6d" providerId="ADAL" clId="{954915EC-4E4C-5938-BB5E-75752EC955AC}" dt="2026-07-17T06:16:48.061" v="549" actId="13244"/>
-          <ac:spMkLst>
-            <pc:docMk/>
-            <pc:sldMk cId="0" sldId="260"/>
-            <ac:spMk id="5" creationId="{00000000-0000-0000-0000-000000000000}"/>
-          </ac:spMkLst>
-        </pc:spChg>
-        <pc:spChg chg="ord">
-          <ac:chgData name="Allan, John" userId="e8ef1c47-ed91-448d-adaf-3df63196cc6d" providerId="ADAL" clId="{954915EC-4E4C-5938-BB5E-75752EC955AC}" dt="2026-07-17T06:17:02.083" v="551" actId="13244"/>
-          <ac:spMkLst>
-            <pc:docMk/>
-            <pc:sldMk cId="0" sldId="260"/>
-            <ac:spMk id="7" creationId="{00000000-0000-0000-0000-000000000000}"/>
-          </ac:spMkLst>
-        </pc:spChg>
-        <pc:spChg chg="ord">
-          <ac:chgData name="Allan, John" userId="e8ef1c47-ed91-448d-adaf-3df63196cc6d" providerId="ADAL" clId="{954915EC-4E4C-5938-BB5E-75752EC955AC}" dt="2026-07-17T06:17:16.572" v="553" actId="13244"/>
-          <ac:spMkLst>
-            <pc:docMk/>
-            <pc:sldMk cId="0" sldId="260"/>
-            <ac:spMk id="16" creationId="{00000000-0000-0000-0000-000000000000}"/>
-          </ac:spMkLst>
-        </pc:spChg>
-        <pc:spChg chg="ord">
-          <ac:chgData name="Allan, John" userId="e8ef1c47-ed91-448d-adaf-3df63196cc6d" providerId="ADAL" clId="{954915EC-4E4C-5938-BB5E-75752EC955AC}" dt="2026-07-17T06:17:14.401" v="552" actId="13244"/>
-          <ac:spMkLst>
-            <pc:docMk/>
-            <pc:sldMk cId="0" sldId="260"/>
-            <ac:spMk id="17" creationId="{00000000-0000-0000-0000-000000000000}"/>
-          </ac:spMkLst>
-        </pc:spChg>
-        <pc:spChg chg="add mod ord">
-          <ac:chgData name="Allan, John" userId="e8ef1c47-ed91-448d-adaf-3df63196cc6d" providerId="ADAL" clId="{954915EC-4E4C-5938-BB5E-75752EC955AC}" dt="2026-07-17T06:16:54.401" v="550" actId="13244"/>
-          <ac:spMkLst>
-            <pc:docMk/>
-            <pc:sldMk cId="0" sldId="260"/>
-            <ac:spMk id="18" creationId="{07F43C91-B4B7-93C8-93AC-6776C1CECA59}"/>
-          </ac:spMkLst>
-        </pc:spChg>
-        <pc:spChg chg="add mod ord">
-          <ac:chgData name="Allan, John" userId="e8ef1c47-ed91-448d-adaf-3df63196cc6d" providerId="ADAL" clId="{954915EC-4E4C-5938-BB5E-75752EC955AC}" dt="2026-07-17T06:16:54.401" v="550" actId="13244"/>
-          <ac:spMkLst>
-            <pc:docMk/>
-            <pc:sldMk cId="0" sldId="260"/>
-            <ac:spMk id="19" creationId="{F71EF808-DA70-00FF-7FD9-5DE23C94EC08}"/>
-          </ac:spMkLst>
-        </pc:spChg>
-      </pc:sldChg>
-      <pc:sldChg chg="del">
-        <pc:chgData name="Allan, John" userId="e8ef1c47-ed91-448d-adaf-3df63196cc6d" providerId="ADAL" clId="{954915EC-4E4C-5938-BB5E-75752EC955AC}" dt="2026-07-17T05:49:46.137" v="238" actId="2696"/>
-        <pc:sldMkLst>
-          <pc:docMk/>
-          <pc:sldMk cId="0" sldId="261"/>
-        </pc:sldMkLst>
-      </pc:sldChg>
-      <pc:sldChg chg="add del setBg">
-        <pc:chgData name="Allan, John" userId="e8ef1c47-ed91-448d-adaf-3df63196cc6d" providerId="ADAL" clId="{954915EC-4E4C-5938-BB5E-75752EC955AC}" dt="2026-07-17T05:50:13.780" v="242"/>
-        <pc:sldMkLst>
-          <pc:docMk/>
-          <pc:sldMk cId="2292975729" sldId="261"/>
-        </pc:sldMkLst>
-      </pc:sldChg>
-      <pc:sldChg chg="addSp delSp modSp mod ord">
-        <pc:chgData name="Allan, John" userId="e8ef1c47-ed91-448d-adaf-3df63196cc6d" providerId="ADAL" clId="{954915EC-4E4C-5938-BB5E-75752EC955AC}" dt="2026-07-17T06:15:25.770" v="540" actId="13244"/>
-        <pc:sldMkLst>
-          <pc:docMk/>
-          <pc:sldMk cId="0" sldId="262"/>
-        </pc:sldMkLst>
-        <pc:spChg chg="del">
-          <ac:chgData name="Allan, John" userId="e8ef1c47-ed91-448d-adaf-3df63196cc6d" providerId="ADAL" clId="{954915EC-4E4C-5938-BB5E-75752EC955AC}" dt="2026-07-17T05:40:17.674" v="201" actId="478"/>
-          <ac:spMkLst>
-            <pc:docMk/>
-            <pc:sldMk cId="0" sldId="262"/>
-            <ac:spMk id="3" creationId="{00000000-0000-0000-0000-000000000000}"/>
-          </ac:spMkLst>
-        </pc:spChg>
-        <pc:spChg chg="del">
-          <ac:chgData name="Allan, John" userId="e8ef1c47-ed91-448d-adaf-3df63196cc6d" providerId="ADAL" clId="{954915EC-4E4C-5938-BB5E-75752EC955AC}" dt="2026-07-17T05:40:16.816" v="200" actId="478"/>
-          <ac:spMkLst>
-            <pc:docMk/>
-            <pc:sldMk cId="0" sldId="262"/>
-            <ac:spMk id="4" creationId="{00000000-0000-0000-0000-000000000000}"/>
-          </ac:spMkLst>
-        </pc:spChg>
-        <pc:spChg chg="mod ord">
-          <ac:chgData name="Allan, John" userId="e8ef1c47-ed91-448d-adaf-3df63196cc6d" providerId="ADAL" clId="{954915EC-4E4C-5938-BB5E-75752EC955AC}" dt="2026-07-17T06:15:02.243" v="538" actId="13244"/>
-          <ac:spMkLst>
-            <pc:docMk/>
-            <pc:sldMk cId="0" sldId="262"/>
-            <ac:spMk id="5" creationId="{00000000-0000-0000-0000-000000000000}"/>
-          </ac:spMkLst>
-        </pc:spChg>
-        <pc:spChg chg="mod">
-          <ac:chgData name="Allan, John" userId="e8ef1c47-ed91-448d-adaf-3df63196cc6d" providerId="ADAL" clId="{954915EC-4E4C-5938-BB5E-75752EC955AC}" dt="2026-07-17T05:40:42.598" v="228" actId="20577"/>
-          <ac:spMkLst>
-            <pc:docMk/>
-            <pc:sldMk cId="0" sldId="262"/>
-            <ac:spMk id="6" creationId="{00000000-0000-0000-0000-000000000000}"/>
-          </ac:spMkLst>
-        </pc:spChg>
-        <pc:spChg chg="ord">
-          <ac:chgData name="Allan, John" userId="e8ef1c47-ed91-448d-adaf-3df63196cc6d" providerId="ADAL" clId="{954915EC-4E4C-5938-BB5E-75752EC955AC}" dt="2026-07-17T06:15:25.770" v="540" actId="13244"/>
-          <ac:spMkLst>
-            <pc:docMk/>
-            <pc:sldMk cId="0" sldId="262"/>
-            <ac:spMk id="7" creationId="{00000000-0000-0000-0000-000000000000}"/>
-          </ac:spMkLst>
-        </pc:spChg>
-        <pc:spChg chg="mod">
-          <ac:chgData name="Allan, John" userId="e8ef1c47-ed91-448d-adaf-3df63196cc6d" providerId="ADAL" clId="{954915EC-4E4C-5938-BB5E-75752EC955AC}" dt="2026-07-17T04:45:03.543" v="62" actId="20577"/>
-          <ac:spMkLst>
-            <pc:docMk/>
-            <pc:sldMk cId="0" sldId="262"/>
-            <ac:spMk id="105" creationId="{00000000-0000-0000-0000-000000000000}"/>
-          </ac:spMkLst>
-        </pc:spChg>
-        <pc:spChg chg="add mod ord">
-          <ac:chgData name="Allan, John" userId="e8ef1c47-ed91-448d-adaf-3df63196cc6d" providerId="ADAL" clId="{954915EC-4E4C-5938-BB5E-75752EC955AC}" dt="2026-07-17T06:15:15.807" v="539" actId="13244"/>
-          <ac:spMkLst>
-            <pc:docMk/>
-            <pc:sldMk cId="0" sldId="262"/>
-            <ac:spMk id="137" creationId="{4D16B1E6-BE1F-94A5-FBCC-366E6DE66CA0}"/>
-          </ac:spMkLst>
-        </pc:spChg>
-        <pc:spChg chg="add mod ord">
-          <ac:chgData name="Allan, John" userId="e8ef1c47-ed91-448d-adaf-3df63196cc6d" providerId="ADAL" clId="{954915EC-4E4C-5938-BB5E-75752EC955AC}" dt="2026-07-17T06:14:58.589" v="537" actId="13244"/>
-          <ac:spMkLst>
-            <pc:docMk/>
-            <pc:sldMk cId="0" sldId="262"/>
-            <ac:spMk id="138" creationId="{A4FE6505-AE80-9E68-05FE-81D37075A1E4}"/>
-          </ac:spMkLst>
-        </pc:spChg>
-      </pc:sldChg>
-      <pc:sldChg chg="addSp delSp modSp mod">
-        <pc:chgData name="Allan, John" userId="e8ef1c47-ed91-448d-adaf-3df63196cc6d" providerId="ADAL" clId="{954915EC-4E4C-5938-BB5E-75752EC955AC}" dt="2026-07-17T06:18:48.907" v="564" actId="13244"/>
-        <pc:sldMkLst>
-          <pc:docMk/>
-          <pc:sldMk cId="0" sldId="263"/>
-        </pc:sldMkLst>
-        <pc:spChg chg="del">
-          <ac:chgData name="Allan, John" userId="e8ef1c47-ed91-448d-adaf-3df63196cc6d" providerId="ADAL" clId="{954915EC-4E4C-5938-BB5E-75752EC955AC}" dt="2026-07-17T05:50:11.880" v="240" actId="478"/>
-          <ac:spMkLst>
-            <pc:docMk/>
-            <pc:sldMk cId="0" sldId="263"/>
-            <ac:spMk id="3" creationId="{00000000-0000-0000-0000-000000000000}"/>
-          </ac:spMkLst>
-        </pc:spChg>
-        <pc:spChg chg="del">
-          <ac:chgData name="Allan, John" userId="e8ef1c47-ed91-448d-adaf-3df63196cc6d" providerId="ADAL" clId="{954915EC-4E4C-5938-BB5E-75752EC955AC}" dt="2026-07-17T05:50:11.160" v="239" actId="478"/>
-          <ac:spMkLst>
-            <pc:docMk/>
-            <pc:sldMk cId="0" sldId="263"/>
-            <ac:spMk id="4" creationId="{00000000-0000-0000-0000-000000000000}"/>
-          </ac:spMkLst>
-        </pc:spChg>
-        <pc:spChg chg="ord">
-          <ac:chgData name="Allan, John" userId="e8ef1c47-ed91-448d-adaf-3df63196cc6d" providerId="ADAL" clId="{954915EC-4E4C-5938-BB5E-75752EC955AC}" dt="2026-07-17T06:18:38.517" v="562" actId="13244"/>
-          <ac:spMkLst>
-            <pc:docMk/>
-            <pc:sldMk cId="0" sldId="263"/>
-            <ac:spMk id="5" creationId="{00000000-0000-0000-0000-000000000000}"/>
-          </ac:spMkLst>
-        </pc:spChg>
-        <pc:spChg chg="ord">
-          <ac:chgData name="Allan, John" userId="e8ef1c47-ed91-448d-adaf-3df63196cc6d" providerId="ADAL" clId="{954915EC-4E4C-5938-BB5E-75752EC955AC}" dt="2026-07-17T06:18:48.907" v="564" actId="13244"/>
-          <ac:spMkLst>
-            <pc:docMk/>
-            <pc:sldMk cId="0" sldId="263"/>
-            <ac:spMk id="7" creationId="{00000000-0000-0000-0000-000000000000}"/>
-          </ac:spMkLst>
-        </pc:spChg>
-        <pc:spChg chg="mod">
-          <ac:chgData name="Allan, John" userId="e8ef1c47-ed91-448d-adaf-3df63196cc6d" providerId="ADAL" clId="{954915EC-4E4C-5938-BB5E-75752EC955AC}" dt="2026-07-17T04:46:38.210" v="68" actId="20577"/>
-          <ac:spMkLst>
-            <pc:docMk/>
-            <pc:sldMk cId="0" sldId="263"/>
-            <ac:spMk id="27" creationId="{00000000-0000-0000-0000-000000000000}"/>
-          </ac:spMkLst>
-        </pc:spChg>
-        <pc:spChg chg="add mod ord">
-          <ac:chgData name="Allan, John" userId="e8ef1c47-ed91-448d-adaf-3df63196cc6d" providerId="ADAL" clId="{954915EC-4E4C-5938-BB5E-75752EC955AC}" dt="2026-07-17T06:18:43.547" v="563" actId="13244"/>
-          <ac:spMkLst>
-            <pc:docMk/>
-            <pc:sldMk cId="0" sldId="263"/>
-            <ac:spMk id="41" creationId="{41AB592D-30DF-CBDC-C9F7-F747A768F8B9}"/>
-          </ac:spMkLst>
-        </pc:spChg>
-        <pc:spChg chg="add mod ord">
-          <ac:chgData name="Allan, John" userId="e8ef1c47-ed91-448d-adaf-3df63196cc6d" providerId="ADAL" clId="{954915EC-4E4C-5938-BB5E-75752EC955AC}" dt="2026-07-17T06:18:43.547" v="563" actId="13244"/>
-          <ac:spMkLst>
-            <pc:docMk/>
-            <pc:sldMk cId="0" sldId="263"/>
-            <ac:spMk id="42" creationId="{82FB94D3-F17D-143D-3601-31DC50D215B0}"/>
-          </ac:spMkLst>
-        </pc:spChg>
-      </pc:sldChg>
-      <pc:sldChg chg="del ord">
-        <pc:chgData name="Allan, John" userId="e8ef1c47-ed91-448d-adaf-3df63196cc6d" providerId="ADAL" clId="{954915EC-4E4C-5938-BB5E-75752EC955AC}" dt="2026-07-17T05:52:44.135" v="250" actId="2696"/>
-        <pc:sldMkLst>
-          <pc:docMk/>
-          <pc:sldMk cId="0" sldId="264"/>
-        </pc:sldMkLst>
-      </pc:sldChg>
-      <pc:sldChg chg="modSp mod">
-        <pc:chgData name="Allan, John" userId="e8ef1c47-ed91-448d-adaf-3df63196cc6d" providerId="ADAL" clId="{954915EC-4E4C-5938-BB5E-75752EC955AC}" dt="2026-07-17T06:19:14.088" v="566" actId="13244"/>
-        <pc:sldMkLst>
-          <pc:docMk/>
-          <pc:sldMk cId="0" sldId="265"/>
-        </pc:sldMkLst>
-        <pc:spChg chg="ord">
-          <ac:chgData name="Allan, John" userId="e8ef1c47-ed91-448d-adaf-3df63196cc6d" providerId="ADAL" clId="{954915EC-4E4C-5938-BB5E-75752EC955AC}" dt="2026-07-17T06:19:10.519" v="565" actId="13244"/>
-          <ac:spMkLst>
-            <pc:docMk/>
-            <pc:sldMk cId="0" sldId="265"/>
-            <ac:spMk id="5" creationId="{00000000-0000-0000-0000-000000000000}"/>
-          </ac:spMkLst>
-        </pc:spChg>
-        <pc:spChg chg="ord">
-          <ac:chgData name="Allan, John" userId="e8ef1c47-ed91-448d-adaf-3df63196cc6d" providerId="ADAL" clId="{954915EC-4E4C-5938-BB5E-75752EC955AC}" dt="2026-07-17T06:19:14.088" v="566" actId="13244"/>
-          <ac:spMkLst>
-            <pc:docMk/>
-            <pc:sldMk cId="0" sldId="265"/>
-            <ac:spMk id="7" creationId="{00000000-0000-0000-0000-000000000000}"/>
-          </ac:spMkLst>
-        </pc:spChg>
-      </pc:sldChg>
-      <pc:sldChg chg="delSp modSp mod">
-        <pc:chgData name="Allan, John" userId="e8ef1c47-ed91-448d-adaf-3df63196cc6d" providerId="ADAL" clId="{954915EC-4E4C-5938-BB5E-75752EC955AC}" dt="2026-07-17T06:19:29.080" v="568" actId="13244"/>
-        <pc:sldMkLst>
-          <pc:docMk/>
-          <pc:sldMk cId="0" sldId="266"/>
-        </pc:sldMkLst>
-        <pc:spChg chg="ord">
-          <ac:chgData name="Allan, John" userId="e8ef1c47-ed91-448d-adaf-3df63196cc6d" providerId="ADAL" clId="{954915EC-4E4C-5938-BB5E-75752EC955AC}" dt="2026-07-17T06:19:23.980" v="567" actId="13244"/>
-          <ac:spMkLst>
-            <pc:docMk/>
-            <pc:sldMk cId="0" sldId="266"/>
-            <ac:spMk id="5" creationId="{00000000-0000-0000-0000-000000000000}"/>
-          </ac:spMkLst>
-        </pc:spChg>
-        <pc:spChg chg="ord">
-          <ac:chgData name="Allan, John" userId="e8ef1c47-ed91-448d-adaf-3df63196cc6d" providerId="ADAL" clId="{954915EC-4E4C-5938-BB5E-75752EC955AC}" dt="2026-07-17T06:19:29.080" v="568" actId="13244"/>
-          <ac:spMkLst>
-            <pc:docMk/>
-            <pc:sldMk cId="0" sldId="266"/>
-            <ac:spMk id="7" creationId="{00000000-0000-0000-0000-000000000000}"/>
-          </ac:spMkLst>
-        </pc:spChg>
-        <pc:spChg chg="del">
-          <ac:chgData name="Allan, John" userId="e8ef1c47-ed91-448d-adaf-3df63196cc6d" providerId="ADAL" clId="{954915EC-4E4C-5938-BB5E-75752EC955AC}" dt="2026-07-17T05:52:00.250" v="248" actId="478"/>
-          <ac:spMkLst>
-            <pc:docMk/>
-            <pc:sldMk cId="0" sldId="266"/>
-            <ac:spMk id="23" creationId="{00000000-0000-0000-0000-000000000000}"/>
-          </ac:spMkLst>
-        </pc:spChg>
-        <pc:spChg chg="del">
-          <ac:chgData name="Allan, John" userId="e8ef1c47-ed91-448d-adaf-3df63196cc6d" providerId="ADAL" clId="{954915EC-4E4C-5938-BB5E-75752EC955AC}" dt="2026-07-17T05:52:02.826" v="249" actId="478"/>
-          <ac:spMkLst>
-            <pc:docMk/>
-            <pc:sldMk cId="0" sldId="266"/>
-            <ac:spMk id="24" creationId="{00000000-0000-0000-0000-000000000000}"/>
-          </ac:spMkLst>
-        </pc:spChg>
-      </pc:sldChg>
-      <pc:sldChg chg="modSp mod">
-        <pc:chgData name="Allan, John" userId="e8ef1c47-ed91-448d-adaf-3df63196cc6d" providerId="ADAL" clId="{954915EC-4E4C-5938-BB5E-75752EC955AC}" dt="2026-07-17T06:19:43.696" v="570" actId="13244"/>
-        <pc:sldMkLst>
-          <pc:docMk/>
-          <pc:sldMk cId="0" sldId="267"/>
-        </pc:sldMkLst>
-        <pc:spChg chg="ord">
-          <ac:chgData name="Allan, John" userId="e8ef1c47-ed91-448d-adaf-3df63196cc6d" providerId="ADAL" clId="{954915EC-4E4C-5938-BB5E-75752EC955AC}" dt="2026-07-17T06:19:37.650" v="569" actId="13244"/>
-          <ac:spMkLst>
-            <pc:docMk/>
-            <pc:sldMk cId="0" sldId="267"/>
-            <ac:spMk id="5" creationId="{00000000-0000-0000-0000-000000000000}"/>
-          </ac:spMkLst>
-        </pc:spChg>
-        <pc:spChg chg="ord">
-          <ac:chgData name="Allan, John" userId="e8ef1c47-ed91-448d-adaf-3df63196cc6d" providerId="ADAL" clId="{954915EC-4E4C-5938-BB5E-75752EC955AC}" dt="2026-07-17T06:19:43.696" v="570" actId="13244"/>
-          <ac:spMkLst>
-            <pc:docMk/>
-            <pc:sldMk cId="0" sldId="267"/>
-            <ac:spMk id="7" creationId="{00000000-0000-0000-0000-000000000000}"/>
-          </ac:spMkLst>
-        </pc:spChg>
-      </pc:sldChg>
-      <pc:sldChg chg="modSp mod">
-        <pc:chgData name="Allan, John" userId="e8ef1c47-ed91-448d-adaf-3df63196cc6d" providerId="ADAL" clId="{954915EC-4E4C-5938-BB5E-75752EC955AC}" dt="2026-07-17T06:20:00.921" v="572" actId="13244"/>
-        <pc:sldMkLst>
-          <pc:docMk/>
-          <pc:sldMk cId="0" sldId="269"/>
-        </pc:sldMkLst>
-        <pc:spChg chg="ord">
-          <ac:chgData name="Allan, John" userId="e8ef1c47-ed91-448d-adaf-3df63196cc6d" providerId="ADAL" clId="{954915EC-4E4C-5938-BB5E-75752EC955AC}" dt="2026-07-17T06:19:53.191" v="571" actId="13244"/>
-          <ac:spMkLst>
-            <pc:docMk/>
-            <pc:sldMk cId="0" sldId="269"/>
-            <ac:spMk id="5" creationId="{00000000-0000-0000-0000-000000000000}"/>
-          </ac:spMkLst>
-        </pc:spChg>
-        <pc:spChg chg="ord">
-          <ac:chgData name="Allan, John" userId="e8ef1c47-ed91-448d-adaf-3df63196cc6d" providerId="ADAL" clId="{954915EC-4E4C-5938-BB5E-75752EC955AC}" dt="2026-07-17T06:20:00.921" v="572" actId="13244"/>
-          <ac:spMkLst>
-            <pc:docMk/>
-            <pc:sldMk cId="0" sldId="269"/>
-            <ac:spMk id="7" creationId="{00000000-0000-0000-0000-000000000000}"/>
-          </ac:spMkLst>
-        </pc:spChg>
-      </pc:sldChg>
-      <pc:sldChg chg="modSp mod">
-        <pc:chgData name="Allan, John" userId="e8ef1c47-ed91-448d-adaf-3df63196cc6d" providerId="ADAL" clId="{954915EC-4E4C-5938-BB5E-75752EC955AC}" dt="2026-07-17T06:20:13.409" v="574" actId="13244"/>
-        <pc:sldMkLst>
-          <pc:docMk/>
-          <pc:sldMk cId="0" sldId="270"/>
-        </pc:sldMkLst>
-        <pc:spChg chg="ord">
-          <ac:chgData name="Allan, John" userId="e8ef1c47-ed91-448d-adaf-3df63196cc6d" providerId="ADAL" clId="{954915EC-4E4C-5938-BB5E-75752EC955AC}" dt="2026-07-17T06:20:08.692" v="573" actId="13244"/>
-          <ac:spMkLst>
-            <pc:docMk/>
-            <pc:sldMk cId="0" sldId="270"/>
-            <ac:spMk id="5" creationId="{00000000-0000-0000-0000-000000000000}"/>
-          </ac:spMkLst>
-        </pc:spChg>
-        <pc:spChg chg="ord">
-          <ac:chgData name="Allan, John" userId="e8ef1c47-ed91-448d-adaf-3df63196cc6d" providerId="ADAL" clId="{954915EC-4E4C-5938-BB5E-75752EC955AC}" dt="2026-07-17T06:20:13.409" v="574" actId="13244"/>
-          <ac:spMkLst>
-            <pc:docMk/>
-            <pc:sldMk cId="0" sldId="270"/>
-            <ac:spMk id="7" creationId="{00000000-0000-0000-0000-000000000000}"/>
-          </ac:spMkLst>
-        </pc:spChg>
-        <pc:spChg chg="mod">
-          <ac:chgData name="Allan, John" userId="e8ef1c47-ed91-448d-adaf-3df63196cc6d" providerId="ADAL" clId="{954915EC-4E4C-5938-BB5E-75752EC955AC}" dt="2026-07-17T05:53:09.685" v="262" actId="20577"/>
-          <ac:spMkLst>
-            <pc:docMk/>
-            <pc:sldMk cId="0" sldId="270"/>
-            <ac:spMk id="55" creationId="{00000000-0000-0000-0000-000000000000}"/>
-          </ac:spMkLst>
-        </pc:spChg>
-      </pc:sldChg>
-      <pc:sldChg chg="modSp mod">
-        <pc:chgData name="Allan, John" userId="e8ef1c47-ed91-448d-adaf-3df63196cc6d" providerId="ADAL" clId="{954915EC-4E4C-5938-BB5E-75752EC955AC}" dt="2026-07-17T06:20:23.703" v="576" actId="13244"/>
-        <pc:sldMkLst>
-          <pc:docMk/>
-          <pc:sldMk cId="0" sldId="271"/>
-        </pc:sldMkLst>
-        <pc:spChg chg="mod ord">
-          <ac:chgData name="Allan, John" userId="e8ef1c47-ed91-448d-adaf-3df63196cc6d" providerId="ADAL" clId="{954915EC-4E4C-5938-BB5E-75752EC955AC}" dt="2026-07-17T06:20:21.014" v="575" actId="13244"/>
-          <ac:spMkLst>
-            <pc:docMk/>
-            <pc:sldMk cId="0" sldId="271"/>
-            <ac:spMk id="5" creationId="{00000000-0000-0000-0000-000000000000}"/>
-          </ac:spMkLst>
-        </pc:spChg>
-        <pc:spChg chg="ord">
-          <ac:chgData name="Allan, John" userId="e8ef1c47-ed91-448d-adaf-3df63196cc6d" providerId="ADAL" clId="{954915EC-4E4C-5938-BB5E-75752EC955AC}" dt="2026-07-17T06:20:23.703" v="576" actId="13244"/>
-          <ac:spMkLst>
-            <pc:docMk/>
-            <pc:sldMk cId="0" sldId="271"/>
-            <ac:spMk id="7" creationId="{00000000-0000-0000-0000-000000000000}"/>
-          </ac:spMkLst>
-        </pc:spChg>
-      </pc:sldChg>
-      <pc:sldChg chg="del">
-        <pc:chgData name="Allan, John" userId="e8ef1c47-ed91-448d-adaf-3df63196cc6d" providerId="ADAL" clId="{954915EC-4E4C-5938-BB5E-75752EC955AC}" dt="2026-07-17T05:53:59.419" v="263" actId="2696"/>
-        <pc:sldMkLst>
-          <pc:docMk/>
-          <pc:sldMk cId="0" sldId="272"/>
-        </pc:sldMkLst>
-      </pc:sldChg>
-      <pc:sldChg chg="modSp mod">
-        <pc:chgData name="Allan, John" userId="e8ef1c47-ed91-448d-adaf-3df63196cc6d" providerId="ADAL" clId="{954915EC-4E4C-5938-BB5E-75752EC955AC}" dt="2026-07-17T06:20:34.131" v="578" actId="13244"/>
-        <pc:sldMkLst>
-          <pc:docMk/>
-          <pc:sldMk cId="0" sldId="273"/>
-        </pc:sldMkLst>
-        <pc:spChg chg="ord">
-          <ac:chgData name="Allan, John" userId="e8ef1c47-ed91-448d-adaf-3df63196cc6d" providerId="ADAL" clId="{954915EC-4E4C-5938-BB5E-75752EC955AC}" dt="2026-07-17T06:20:31.319" v="577" actId="13244"/>
-          <ac:spMkLst>
-            <pc:docMk/>
-            <pc:sldMk cId="0" sldId="273"/>
-            <ac:spMk id="5" creationId="{00000000-0000-0000-0000-000000000000}"/>
-          </ac:spMkLst>
-        </pc:spChg>
-        <pc:spChg chg="ord">
-          <ac:chgData name="Allan, John" userId="e8ef1c47-ed91-448d-adaf-3df63196cc6d" providerId="ADAL" clId="{954915EC-4E4C-5938-BB5E-75752EC955AC}" dt="2026-07-17T06:20:34.131" v="578" actId="13244"/>
-          <ac:spMkLst>
-            <pc:docMk/>
-            <pc:sldMk cId="0" sldId="273"/>
-            <ac:spMk id="7" creationId="{00000000-0000-0000-0000-000000000000}"/>
-          </ac:spMkLst>
-        </pc:spChg>
-      </pc:sldChg>
-      <pc:sldChg chg="modSp mod">
-        <pc:chgData name="Allan, John" userId="e8ef1c47-ed91-448d-adaf-3df63196cc6d" providerId="ADAL" clId="{954915EC-4E4C-5938-BB5E-75752EC955AC}" dt="2026-07-17T06:20:43.230" v="580" actId="13244"/>
-        <pc:sldMkLst>
-          <pc:docMk/>
-          <pc:sldMk cId="0" sldId="274"/>
-        </pc:sldMkLst>
-        <pc:spChg chg="ord">
-          <ac:chgData name="Allan, John" userId="e8ef1c47-ed91-448d-adaf-3df63196cc6d" providerId="ADAL" clId="{954915EC-4E4C-5938-BB5E-75752EC955AC}" dt="2026-07-17T06:20:40.804" v="579" actId="13244"/>
-          <ac:spMkLst>
-            <pc:docMk/>
-            <pc:sldMk cId="0" sldId="274"/>
-            <ac:spMk id="5" creationId="{00000000-0000-0000-0000-000000000000}"/>
-          </ac:spMkLst>
-        </pc:spChg>
-        <pc:spChg chg="ord">
-          <ac:chgData name="Allan, John" userId="e8ef1c47-ed91-448d-adaf-3df63196cc6d" providerId="ADAL" clId="{954915EC-4E4C-5938-BB5E-75752EC955AC}" dt="2026-07-17T06:20:43.230" v="580" actId="13244"/>
-          <ac:spMkLst>
-            <pc:docMk/>
-            <pc:sldMk cId="0" sldId="274"/>
-            <ac:spMk id="7" creationId="{00000000-0000-0000-0000-000000000000}"/>
-          </ac:spMkLst>
-        </pc:spChg>
-      </pc:sldChg>
-      <pc:sldChg chg="modSp mod">
-        <pc:chgData name="Allan, John" userId="e8ef1c47-ed91-448d-adaf-3df63196cc6d" providerId="ADAL" clId="{954915EC-4E4C-5938-BB5E-75752EC955AC}" dt="2026-07-17T06:20:51.791" v="582" actId="13244"/>
-        <pc:sldMkLst>
-          <pc:docMk/>
-          <pc:sldMk cId="0" sldId="275"/>
-        </pc:sldMkLst>
-        <pc:spChg chg="ord">
-          <ac:chgData name="Allan, John" userId="e8ef1c47-ed91-448d-adaf-3df63196cc6d" providerId="ADAL" clId="{954915EC-4E4C-5938-BB5E-75752EC955AC}" dt="2026-07-17T06:20:49.345" v="581" actId="13244"/>
-          <ac:spMkLst>
-            <pc:docMk/>
-            <pc:sldMk cId="0" sldId="275"/>
-            <ac:spMk id="5" creationId="{00000000-0000-0000-0000-000000000000}"/>
-          </ac:spMkLst>
-        </pc:spChg>
-        <pc:spChg chg="ord">
-          <ac:chgData name="Allan, John" userId="e8ef1c47-ed91-448d-adaf-3df63196cc6d" providerId="ADAL" clId="{954915EC-4E4C-5938-BB5E-75752EC955AC}" dt="2026-07-17T06:20:51.791" v="582" actId="13244"/>
-          <ac:spMkLst>
-            <pc:docMk/>
-            <pc:sldMk cId="0" sldId="275"/>
-            <ac:spMk id="7" creationId="{00000000-0000-0000-0000-000000000000}"/>
-          </ac:spMkLst>
-        </pc:spChg>
-      </pc:sldChg>
-      <pc:sldChg chg="modSp mod">
-        <pc:chgData name="Allan, John" userId="e8ef1c47-ed91-448d-adaf-3df63196cc6d" providerId="ADAL" clId="{954915EC-4E4C-5938-BB5E-75752EC955AC}" dt="2026-07-17T06:21:05.963" v="584" actId="13244"/>
-        <pc:sldMkLst>
-          <pc:docMk/>
-          <pc:sldMk cId="0" sldId="276"/>
-        </pc:sldMkLst>
-        <pc:spChg chg="ord">
-          <ac:chgData name="Allan, John" userId="e8ef1c47-ed91-448d-adaf-3df63196cc6d" providerId="ADAL" clId="{954915EC-4E4C-5938-BB5E-75752EC955AC}" dt="2026-07-17T06:20:59.057" v="583" actId="13244"/>
-          <ac:spMkLst>
-            <pc:docMk/>
-            <pc:sldMk cId="0" sldId="276"/>
-            <ac:spMk id="5" creationId="{00000000-0000-0000-0000-000000000000}"/>
-          </ac:spMkLst>
-        </pc:spChg>
-        <pc:spChg chg="ord">
-          <ac:chgData name="Allan, John" userId="e8ef1c47-ed91-448d-adaf-3df63196cc6d" providerId="ADAL" clId="{954915EC-4E4C-5938-BB5E-75752EC955AC}" dt="2026-07-17T06:21:05.963" v="584" actId="13244"/>
-          <ac:spMkLst>
-            <pc:docMk/>
-            <pc:sldMk cId="0" sldId="276"/>
-            <ac:spMk id="7" creationId="{00000000-0000-0000-0000-000000000000}"/>
-          </ac:spMkLst>
-        </pc:spChg>
-      </pc:sldChg>
-      <pc:sldChg chg="modSp mod">
-        <pc:chgData name="Allan, John" userId="e8ef1c47-ed91-448d-adaf-3df63196cc6d" providerId="ADAL" clId="{954915EC-4E4C-5938-BB5E-75752EC955AC}" dt="2026-07-17T06:21:17.102" v="586" actId="13244"/>
-        <pc:sldMkLst>
-          <pc:docMk/>
-          <pc:sldMk cId="0" sldId="277"/>
-        </pc:sldMkLst>
-        <pc:spChg chg="mod ord">
-          <ac:chgData name="Allan, John" userId="e8ef1c47-ed91-448d-adaf-3df63196cc6d" providerId="ADAL" clId="{954915EC-4E4C-5938-BB5E-75752EC955AC}" dt="2026-07-17T06:21:13.358" v="585" actId="13244"/>
-          <ac:spMkLst>
-            <pc:docMk/>
-            <pc:sldMk cId="0" sldId="277"/>
-            <ac:spMk id="5" creationId="{00000000-0000-0000-0000-000000000000}"/>
-          </ac:spMkLst>
-        </pc:spChg>
-        <pc:spChg chg="ord">
-          <ac:chgData name="Allan, John" userId="e8ef1c47-ed91-448d-adaf-3df63196cc6d" providerId="ADAL" clId="{954915EC-4E4C-5938-BB5E-75752EC955AC}" dt="2026-07-17T06:21:17.102" v="586" actId="13244"/>
-          <ac:spMkLst>
-            <pc:docMk/>
-            <pc:sldMk cId="0" sldId="277"/>
-            <ac:spMk id="7" creationId="{00000000-0000-0000-0000-000000000000}"/>
-          </ac:spMkLst>
-        </pc:spChg>
-      </pc:sldChg>
-      <pc:sldChg chg="del">
-        <pc:chgData name="Allan, John" userId="e8ef1c47-ed91-448d-adaf-3df63196cc6d" providerId="ADAL" clId="{954915EC-4E4C-5938-BB5E-75752EC955AC}" dt="2026-07-17T05:58:43.990" v="268" actId="2696"/>
-        <pc:sldMkLst>
-          <pc:docMk/>
-          <pc:sldMk cId="0" sldId="278"/>
-        </pc:sldMkLst>
-      </pc:sldChg>
-      <pc:sldChg chg="modSp mod ord">
-        <pc:chgData name="Allan, John" userId="e8ef1c47-ed91-448d-adaf-3df63196cc6d" providerId="ADAL" clId="{954915EC-4E4C-5938-BB5E-75752EC955AC}" dt="2026-07-17T06:22:46.848" v="595" actId="13244"/>
-        <pc:sldMkLst>
-          <pc:docMk/>
-          <pc:sldMk cId="0" sldId="279"/>
-        </pc:sldMkLst>
-        <pc:spChg chg="mod">
-          <ac:chgData name="Allan, John" userId="e8ef1c47-ed91-448d-adaf-3df63196cc6d" providerId="ADAL" clId="{954915EC-4E4C-5938-BB5E-75752EC955AC}" dt="2026-07-17T05:58:52.865" v="280" actId="20577"/>
-          <ac:spMkLst>
-            <pc:docMk/>
-            <pc:sldMk cId="0" sldId="279"/>
-            <ac:spMk id="4" creationId="{00000000-0000-0000-0000-000000000000}"/>
-          </ac:spMkLst>
-        </pc:spChg>
-        <pc:spChg chg="ord">
-          <ac:chgData name="Allan, John" userId="e8ef1c47-ed91-448d-adaf-3df63196cc6d" providerId="ADAL" clId="{954915EC-4E4C-5938-BB5E-75752EC955AC}" dt="2026-07-17T06:22:20.620" v="594" actId="13244"/>
-          <ac:spMkLst>
-            <pc:docMk/>
-            <pc:sldMk cId="0" sldId="279"/>
-            <ac:spMk id="5" creationId="{00000000-0000-0000-0000-000000000000}"/>
-          </ac:spMkLst>
-        </pc:spChg>
-        <pc:spChg chg="ord">
-          <ac:chgData name="Allan, John" userId="e8ef1c47-ed91-448d-adaf-3df63196cc6d" providerId="ADAL" clId="{954915EC-4E4C-5938-BB5E-75752EC955AC}" dt="2026-07-17T06:22:46.848" v="595" actId="13244"/>
-          <ac:spMkLst>
-            <pc:docMk/>
-            <pc:sldMk cId="0" sldId="279"/>
-            <ac:spMk id="7" creationId="{00000000-0000-0000-0000-000000000000}"/>
-          </ac:spMkLst>
-        </pc:spChg>
-      </pc:sldChg>
-      <pc:sldChg chg="addSp delSp modSp mod ord">
-        <pc:chgData name="Allan, John" userId="e8ef1c47-ed91-448d-adaf-3df63196cc6d" providerId="ADAL" clId="{954915EC-4E4C-5938-BB5E-75752EC955AC}" dt="2026-07-17T06:23:20.340" v="600" actId="13244"/>
-        <pc:sldMkLst>
-          <pc:docMk/>
-          <pc:sldMk cId="0" sldId="280"/>
-        </pc:sldMkLst>
-        <pc:spChg chg="del">
-          <ac:chgData name="Allan, John" userId="e8ef1c47-ed91-448d-adaf-3df63196cc6d" providerId="ADAL" clId="{954915EC-4E4C-5938-BB5E-75752EC955AC}" dt="2026-07-17T05:59:04.286" v="281" actId="478"/>
-          <ac:spMkLst>
-            <pc:docMk/>
-            <pc:sldMk cId="0" sldId="280"/>
-            <ac:spMk id="3" creationId="{00000000-0000-0000-0000-000000000000}"/>
-          </ac:spMkLst>
-        </pc:spChg>
-        <pc:spChg chg="del">
-          <ac:chgData name="Allan, John" userId="e8ef1c47-ed91-448d-adaf-3df63196cc6d" providerId="ADAL" clId="{954915EC-4E4C-5938-BB5E-75752EC955AC}" dt="2026-07-17T05:59:12.251" v="286" actId="478"/>
-          <ac:spMkLst>
-            <pc:docMk/>
-            <pc:sldMk cId="0" sldId="280"/>
-            <ac:spMk id="4" creationId="{00000000-0000-0000-0000-000000000000}"/>
-          </ac:spMkLst>
-        </pc:spChg>
-        <pc:spChg chg="mod ord">
-          <ac:chgData name="Allan, John" userId="e8ef1c47-ed91-448d-adaf-3df63196cc6d" providerId="ADAL" clId="{954915EC-4E4C-5938-BB5E-75752EC955AC}" dt="2026-07-17T06:22:55.370" v="597" actId="13244"/>
-          <ac:spMkLst>
-            <pc:docMk/>
-            <pc:sldMk cId="0" sldId="280"/>
-            <ac:spMk id="5" creationId="{00000000-0000-0000-0000-000000000000}"/>
-          </ac:spMkLst>
-        </pc:spChg>
-        <pc:spChg chg="ord">
-          <ac:chgData name="Allan, John" userId="e8ef1c47-ed91-448d-adaf-3df63196cc6d" providerId="ADAL" clId="{954915EC-4E4C-5938-BB5E-75752EC955AC}" dt="2026-07-17T06:22:57.972" v="598" actId="13244"/>
-          <ac:spMkLst>
-            <pc:docMk/>
-            <pc:sldMk cId="0" sldId="280"/>
-            <ac:spMk id="6" creationId="{00000000-0000-0000-0000-000000000000}"/>
-          </ac:spMkLst>
-        </pc:spChg>
-        <pc:spChg chg="ord">
-          <ac:chgData name="Allan, John" userId="e8ef1c47-ed91-448d-adaf-3df63196cc6d" providerId="ADAL" clId="{954915EC-4E4C-5938-BB5E-75752EC955AC}" dt="2026-07-17T06:23:20.340" v="600" actId="13244"/>
-          <ac:spMkLst>
-            <pc:docMk/>
-            <pc:sldMk cId="0" sldId="280"/>
-            <ac:spMk id="7" creationId="{00000000-0000-0000-0000-000000000000}"/>
-          </ac:spMkLst>
-        </pc:spChg>
-        <pc:spChg chg="add mod ord">
-          <ac:chgData name="Allan, John" userId="e8ef1c47-ed91-448d-adaf-3df63196cc6d" providerId="ADAL" clId="{954915EC-4E4C-5938-BB5E-75752EC955AC}" dt="2026-07-17T06:23:10.300" v="599" actId="13244"/>
-          <ac:spMkLst>
-            <pc:docMk/>
-            <pc:sldMk cId="0" sldId="280"/>
-            <ac:spMk id="42" creationId="{F3F61AD2-1D62-7535-C412-1C2F64A5D2C7}"/>
-          </ac:spMkLst>
-        </pc:spChg>
-        <pc:spChg chg="add mod ord">
-          <ac:chgData name="Allan, John" userId="e8ef1c47-ed91-448d-adaf-3df63196cc6d" providerId="ADAL" clId="{954915EC-4E4C-5938-BB5E-75752EC955AC}" dt="2026-07-17T06:23:10.300" v="599" actId="13244"/>
-          <ac:spMkLst>
-            <pc:docMk/>
-            <pc:sldMk cId="0" sldId="280"/>
-            <ac:spMk id="43" creationId="{2DBD2264-1C78-8ACB-7A4D-1105A52E395B}"/>
-          </ac:spMkLst>
-        </pc:spChg>
-      </pc:sldChg>
-      <pc:sldChg chg="addSp delSp modSp mod ord">
-        <pc:chgData name="Allan, John" userId="e8ef1c47-ed91-448d-adaf-3df63196cc6d" providerId="ADAL" clId="{954915EC-4E4C-5938-BB5E-75752EC955AC}" dt="2026-07-17T06:23:41.755" v="602" actId="13244"/>
-        <pc:sldMkLst>
-          <pc:docMk/>
-          <pc:sldMk cId="0" sldId="281"/>
-        </pc:sldMkLst>
-        <pc:spChg chg="del">
-          <ac:chgData name="Allan, John" userId="e8ef1c47-ed91-448d-adaf-3df63196cc6d" providerId="ADAL" clId="{954915EC-4E4C-5938-BB5E-75752EC955AC}" dt="2026-07-17T05:59:18.534" v="288" actId="478"/>
-          <ac:spMkLst>
-            <pc:docMk/>
-            <pc:sldMk cId="0" sldId="281"/>
-            <ac:spMk id="3" creationId="{00000000-0000-0000-0000-000000000000}"/>
-          </ac:spMkLst>
-        </pc:spChg>
-        <pc:spChg chg="del">
-          <ac:chgData name="Allan, John" userId="e8ef1c47-ed91-448d-adaf-3df63196cc6d" providerId="ADAL" clId="{954915EC-4E4C-5938-BB5E-75752EC955AC}" dt="2026-07-17T05:59:18.534" v="288" actId="478"/>
-          <ac:spMkLst>
-            <pc:docMk/>
-            <pc:sldMk cId="0" sldId="281"/>
-            <ac:spMk id="4" creationId="{00000000-0000-0000-0000-000000000000}"/>
-          </ac:spMkLst>
-        </pc:spChg>
-        <pc:spChg chg="mod">
-          <ac:chgData name="Allan, John" userId="e8ef1c47-ed91-448d-adaf-3df63196cc6d" providerId="ADAL" clId="{954915EC-4E4C-5938-BB5E-75752EC955AC}" dt="2026-07-17T06:12:37.383" v="524" actId="33553"/>
-          <ac:spMkLst>
-            <pc:docMk/>
-            <pc:sldMk cId="0" sldId="281"/>
-            <ac:spMk id="5" creationId="{00000000-0000-0000-0000-000000000000}"/>
-          </ac:spMkLst>
-        </pc:spChg>
-        <pc:spChg chg="ord">
-          <ac:chgData name="Allan, John" userId="e8ef1c47-ed91-448d-adaf-3df63196cc6d" providerId="ADAL" clId="{954915EC-4E4C-5938-BB5E-75752EC955AC}" dt="2026-07-17T06:23:41.755" v="602" actId="13244"/>
-          <ac:spMkLst>
-            <pc:docMk/>
-            <pc:sldMk cId="0" sldId="281"/>
-            <ac:spMk id="7" creationId="{00000000-0000-0000-0000-000000000000}"/>
-          </ac:spMkLst>
-        </pc:spChg>
-        <pc:spChg chg="add mod ord">
-          <ac:chgData name="Allan, John" userId="e8ef1c47-ed91-448d-adaf-3df63196cc6d" providerId="ADAL" clId="{954915EC-4E4C-5938-BB5E-75752EC955AC}" dt="2026-07-17T06:23:31.843" v="601" actId="13244"/>
-          <ac:spMkLst>
-            <pc:docMk/>
-            <pc:sldMk cId="0" sldId="281"/>
-            <ac:spMk id="18" creationId="{F70E446E-7098-E3A2-C594-677D0CCF9581}"/>
-          </ac:spMkLst>
-        </pc:spChg>
-        <pc:spChg chg="add mod ord">
-          <ac:chgData name="Allan, John" userId="e8ef1c47-ed91-448d-adaf-3df63196cc6d" providerId="ADAL" clId="{954915EC-4E4C-5938-BB5E-75752EC955AC}" dt="2026-07-17T06:23:31.843" v="601" actId="13244"/>
-          <ac:spMkLst>
-            <pc:docMk/>
-            <pc:sldMk cId="0" sldId="281"/>
-            <ac:spMk id="19" creationId="{CE8F5B3A-7545-A631-5BDC-057B26737036}"/>
-          </ac:spMkLst>
-        </pc:spChg>
-      </pc:sldChg>
-      <pc:sldChg chg="addSp delSp modSp mod ord">
-        <pc:chgData name="Allan, John" userId="e8ef1c47-ed91-448d-adaf-3df63196cc6d" providerId="ADAL" clId="{954915EC-4E4C-5938-BB5E-75752EC955AC}" dt="2026-07-17T06:24:07.553" v="604" actId="13244"/>
-        <pc:sldMkLst>
-          <pc:docMk/>
-          <pc:sldMk cId="0" sldId="282"/>
-        </pc:sldMkLst>
-        <pc:spChg chg="del">
-          <ac:chgData name="Allan, John" userId="e8ef1c47-ed91-448d-adaf-3df63196cc6d" providerId="ADAL" clId="{954915EC-4E4C-5938-BB5E-75752EC955AC}" dt="2026-07-17T06:03:20.220" v="309" actId="478"/>
-          <ac:spMkLst>
-            <pc:docMk/>
-            <pc:sldMk cId="0" sldId="282"/>
-            <ac:spMk id="3" creationId="{00000000-0000-0000-0000-000000000000}"/>
-          </ac:spMkLst>
-        </pc:spChg>
-        <pc:spChg chg="del">
-          <ac:chgData name="Allan, John" userId="e8ef1c47-ed91-448d-adaf-3df63196cc6d" providerId="ADAL" clId="{954915EC-4E4C-5938-BB5E-75752EC955AC}" dt="2026-07-17T06:03:20.220" v="309" actId="478"/>
-          <ac:spMkLst>
-            <pc:docMk/>
-            <pc:sldMk cId="0" sldId="282"/>
-            <ac:spMk id="4" creationId="{00000000-0000-0000-0000-000000000000}"/>
-          </ac:spMkLst>
-        </pc:spChg>
-        <pc:spChg chg="mod">
-          <ac:chgData name="Allan, John" userId="e8ef1c47-ed91-448d-adaf-3df63196cc6d" providerId="ADAL" clId="{954915EC-4E4C-5938-BB5E-75752EC955AC}" dt="2026-07-17T06:12:38.422" v="525" actId="33553"/>
-          <ac:spMkLst>
-            <pc:docMk/>
-            <pc:sldMk cId="0" sldId="282"/>
-            <ac:spMk id="5" creationId="{00000000-0000-0000-0000-000000000000}"/>
-          </ac:spMkLst>
-        </pc:spChg>
-        <pc:spChg chg="ord">
-          <ac:chgData name="Allan, John" userId="e8ef1c47-ed91-448d-adaf-3df63196cc6d" providerId="ADAL" clId="{954915EC-4E4C-5938-BB5E-75752EC955AC}" dt="2026-07-17T06:23:50.685" v="603" actId="13244"/>
-          <ac:spMkLst>
-            <pc:docMk/>
-            <pc:sldMk cId="0" sldId="282"/>
-            <ac:spMk id="7" creationId="{00000000-0000-0000-0000-000000000000}"/>
-          </ac:spMkLst>
-        </pc:spChg>
-        <pc:spChg chg="add mod ord">
-          <ac:chgData name="Allan, John" userId="e8ef1c47-ed91-448d-adaf-3df63196cc6d" providerId="ADAL" clId="{954915EC-4E4C-5938-BB5E-75752EC955AC}" dt="2026-07-17T06:24:07.553" v="604" actId="13244"/>
-          <ac:spMkLst>
-            <pc:docMk/>
-            <pc:sldMk cId="0" sldId="282"/>
-            <ac:spMk id="26" creationId="{9A0ED042-8909-6972-5447-E2586E7E4D0B}"/>
-          </ac:spMkLst>
-        </pc:spChg>
-        <pc:spChg chg="add mod ord">
-          <ac:chgData name="Allan, John" userId="e8ef1c47-ed91-448d-adaf-3df63196cc6d" providerId="ADAL" clId="{954915EC-4E4C-5938-BB5E-75752EC955AC}" dt="2026-07-17T06:24:07.553" v="604" actId="13244"/>
-          <ac:spMkLst>
-            <pc:docMk/>
-            <pc:sldMk cId="0" sldId="282"/>
-            <ac:spMk id="27" creationId="{6B32F2B8-0F37-2890-FB4B-F068C04D8C8E}"/>
-          </ac:spMkLst>
-        </pc:spChg>
-      </pc:sldChg>
-      <pc:sldChg chg="delSp modSp mod ord">
-        <pc:chgData name="Allan, John" userId="e8ef1c47-ed91-448d-adaf-3df63196cc6d" providerId="ADAL" clId="{954915EC-4E4C-5938-BB5E-75752EC955AC}" dt="2026-07-17T06:14:04.154" v="531" actId="13244"/>
-        <pc:sldMkLst>
-          <pc:docMk/>
-          <pc:sldMk cId="0" sldId="283"/>
-        </pc:sldMkLst>
-        <pc:spChg chg="mod ord">
-          <ac:chgData name="Allan, John" userId="e8ef1c47-ed91-448d-adaf-3df63196cc6d" providerId="ADAL" clId="{954915EC-4E4C-5938-BB5E-75752EC955AC}" dt="2026-07-17T06:13:33.795" v="530" actId="13244"/>
-          <ac:spMkLst>
-            <pc:docMk/>
-            <pc:sldMk cId="0" sldId="283"/>
-            <ac:spMk id="5" creationId="{00000000-0000-0000-0000-000000000000}"/>
-          </ac:spMkLst>
-        </pc:spChg>
-        <pc:spChg chg="ord">
-          <ac:chgData name="Allan, John" userId="e8ef1c47-ed91-448d-adaf-3df63196cc6d" providerId="ADAL" clId="{954915EC-4E4C-5938-BB5E-75752EC955AC}" dt="2026-07-17T06:14:04.154" v="531" actId="13244"/>
-          <ac:spMkLst>
-            <pc:docMk/>
-            <pc:sldMk cId="0" sldId="283"/>
-            <ac:spMk id="7" creationId="{00000000-0000-0000-0000-000000000000}"/>
-          </ac:spMkLst>
-        </pc:spChg>
-        <pc:spChg chg="mod">
-          <ac:chgData name="Allan, John" userId="e8ef1c47-ed91-448d-adaf-3df63196cc6d" providerId="ADAL" clId="{954915EC-4E4C-5938-BB5E-75752EC955AC}" dt="2026-07-17T06:00:37.508" v="292" actId="14100"/>
-          <ac:spMkLst>
-            <pc:docMk/>
-            <pc:sldMk cId="0" sldId="283"/>
-            <ac:spMk id="8" creationId="{00000000-0000-0000-0000-000000000000}"/>
-          </ac:spMkLst>
-        </pc:spChg>
-        <pc:spChg chg="del">
-          <ac:chgData name="Allan, John" userId="e8ef1c47-ed91-448d-adaf-3df63196cc6d" providerId="ADAL" clId="{954915EC-4E4C-5938-BB5E-75752EC955AC}" dt="2026-07-17T06:00:33.958" v="290" actId="21"/>
-          <ac:spMkLst>
-            <pc:docMk/>
-            <pc:sldMk cId="0" sldId="283"/>
-            <ac:spMk id="12" creationId="{00000000-0000-0000-0000-000000000000}"/>
-          </ac:spMkLst>
-        </pc:spChg>
-        <pc:spChg chg="mod">
-          <ac:chgData name="Allan, John" userId="e8ef1c47-ed91-448d-adaf-3df63196cc6d" providerId="ADAL" clId="{954915EC-4E4C-5938-BB5E-75752EC955AC}" dt="2026-07-17T06:00:39.598" v="293" actId="14100"/>
-          <ac:spMkLst>
-            <pc:docMk/>
-            <pc:sldMk cId="0" sldId="283"/>
-            <ac:spMk id="13" creationId="{00000000-0000-0000-0000-000000000000}"/>
-          </ac:spMkLst>
-        </pc:spChg>
-        <pc:spChg chg="mod">
-          <ac:chgData name="Allan, John" userId="e8ef1c47-ed91-448d-adaf-3df63196cc6d" providerId="ADAL" clId="{954915EC-4E4C-5938-BB5E-75752EC955AC}" dt="2026-07-17T06:00:41.578" v="294" actId="14100"/>
-          <ac:spMkLst>
-            <pc:docMk/>
-            <pc:sldMk cId="0" sldId="283"/>
-            <ac:spMk id="18" creationId="{00000000-0000-0000-0000-000000000000}"/>
-          </ac:spMkLst>
-        </pc:spChg>
-        <pc:spChg chg="mod">
-          <ac:chgData name="Allan, John" userId="e8ef1c47-ed91-448d-adaf-3df63196cc6d" providerId="ADAL" clId="{954915EC-4E4C-5938-BB5E-75752EC955AC}" dt="2026-07-17T06:00:43.728" v="295" actId="14100"/>
-          <ac:spMkLst>
-            <pc:docMk/>
-            <pc:sldMk cId="0" sldId="283"/>
-            <ac:spMk id="23" creationId="{00000000-0000-0000-0000-000000000000}"/>
-          </ac:spMkLst>
-        </pc:spChg>
-        <pc:spChg chg="del">
-          <ac:chgData name="Allan, John" userId="e8ef1c47-ed91-448d-adaf-3df63196cc6d" providerId="ADAL" clId="{954915EC-4E4C-5938-BB5E-75752EC955AC}" dt="2026-07-17T06:00:35.486" v="291" actId="21"/>
-          <ac:spMkLst>
-            <pc:docMk/>
-            <pc:sldMk cId="0" sldId="283"/>
-            <ac:spMk id="28" creationId="{00000000-0000-0000-0000-000000000000}"/>
-          </ac:spMkLst>
-        </pc:spChg>
-      </pc:sldChg>
-      <pc:sldChg chg="modSp mod">
-        <pc:chgData name="Allan, John" userId="e8ef1c47-ed91-448d-adaf-3df63196cc6d" providerId="ADAL" clId="{954915EC-4E4C-5938-BB5E-75752EC955AC}" dt="2026-07-17T06:21:29.812" v="588" actId="13244"/>
-        <pc:sldMkLst>
-          <pc:docMk/>
-          <pc:sldMk cId="0" sldId="284"/>
-        </pc:sldMkLst>
-        <pc:spChg chg="ord">
-          <ac:chgData name="Allan, John" userId="e8ef1c47-ed91-448d-adaf-3df63196cc6d" providerId="ADAL" clId="{954915EC-4E4C-5938-BB5E-75752EC955AC}" dt="2026-07-17T06:21:25.616" v="587" actId="13244"/>
-          <ac:spMkLst>
-            <pc:docMk/>
-            <pc:sldMk cId="0" sldId="284"/>
-            <ac:spMk id="5" creationId="{00000000-0000-0000-0000-000000000000}"/>
-          </ac:spMkLst>
-        </pc:spChg>
-        <pc:spChg chg="ord">
-          <ac:chgData name="Allan, John" userId="e8ef1c47-ed91-448d-adaf-3df63196cc6d" providerId="ADAL" clId="{954915EC-4E4C-5938-BB5E-75752EC955AC}" dt="2026-07-17T06:21:29.812" v="588" actId="13244"/>
-          <ac:spMkLst>
-            <pc:docMk/>
-            <pc:sldMk cId="0" sldId="284"/>
-            <ac:spMk id="7" creationId="{00000000-0000-0000-0000-000000000000}"/>
-          </ac:spMkLst>
-        </pc:spChg>
-      </pc:sldChg>
-      <pc:sldChg chg="modSp del mod">
-        <pc:chgData name="Allan, John" userId="e8ef1c47-ed91-448d-adaf-3df63196cc6d" providerId="ADAL" clId="{954915EC-4E4C-5938-BB5E-75752EC955AC}" dt="2026-07-17T06:13:00.210" v="527" actId="2696"/>
-        <pc:sldMkLst>
-          <pc:docMk/>
-          <pc:sldMk cId="0" sldId="285"/>
-        </pc:sldMkLst>
-        <pc:spChg chg="mod">
-          <ac:chgData name="Allan, John" userId="e8ef1c47-ed91-448d-adaf-3df63196cc6d" providerId="ADAL" clId="{954915EC-4E4C-5938-BB5E-75752EC955AC}" dt="2026-07-17T06:12:36.332" v="523" actId="33553"/>
-          <ac:spMkLst>
-            <pc:docMk/>
-            <pc:sldMk cId="0" sldId="285"/>
-            <ac:spMk id="5" creationId="{00000000-0000-0000-0000-000000000000}"/>
-          </ac:spMkLst>
-        </pc:spChg>
-      </pc:sldChg>
-      <pc:sldChg chg="addSp delSp modSp mod ord">
-        <pc:chgData name="Allan, John" userId="e8ef1c47-ed91-448d-adaf-3df63196cc6d" providerId="ADAL" clId="{954915EC-4E4C-5938-BB5E-75752EC955AC}" dt="2026-07-17T06:39:54.871" v="627" actId="167"/>
-        <pc:sldMkLst>
-          <pc:docMk/>
-          <pc:sldMk cId="0" sldId="286"/>
-        </pc:sldMkLst>
-        <pc:spChg chg="del mod">
-          <ac:chgData name="Allan, John" userId="e8ef1c47-ed91-448d-adaf-3df63196cc6d" providerId="ADAL" clId="{954915EC-4E4C-5938-BB5E-75752EC955AC}" dt="2026-07-17T05:36:59.535" v="190" actId="478"/>
-          <ac:spMkLst>
-            <pc:docMk/>
-            <pc:sldMk cId="0" sldId="286"/>
-            <ac:spMk id="3" creationId="{00000000-0000-0000-0000-000000000000}"/>
-          </ac:spMkLst>
-        </pc:spChg>
-        <pc:spChg chg="del mod">
-          <ac:chgData name="Allan, John" userId="e8ef1c47-ed91-448d-adaf-3df63196cc6d" providerId="ADAL" clId="{954915EC-4E4C-5938-BB5E-75752EC955AC}" dt="2026-07-17T05:37:01.198" v="191" actId="478"/>
-          <ac:spMkLst>
-            <pc:docMk/>
-            <pc:sldMk cId="0" sldId="286"/>
-            <ac:spMk id="4" creationId="{00000000-0000-0000-0000-000000000000}"/>
-          </ac:spMkLst>
-        </pc:spChg>
-        <pc:spChg chg="mod ord">
-          <ac:chgData name="Allan, John" userId="e8ef1c47-ed91-448d-adaf-3df63196cc6d" providerId="ADAL" clId="{954915EC-4E4C-5938-BB5E-75752EC955AC}" dt="2026-07-17T06:14:14.078" v="532" actId="13244"/>
-          <ac:spMkLst>
-            <pc:docMk/>
-            <pc:sldMk cId="0" sldId="286"/>
-            <ac:spMk id="5" creationId="{00000000-0000-0000-0000-000000000000}"/>
-          </ac:spMkLst>
-        </pc:spChg>
-        <pc:spChg chg="ord">
-          <ac:chgData name="Allan, John" userId="e8ef1c47-ed91-448d-adaf-3df63196cc6d" providerId="ADAL" clId="{954915EC-4E4C-5938-BB5E-75752EC955AC}" dt="2026-07-17T06:14:17.834" v="533" actId="13244"/>
-          <ac:spMkLst>
-            <pc:docMk/>
-            <pc:sldMk cId="0" sldId="286"/>
-            <ac:spMk id="7" creationId="{00000000-0000-0000-0000-000000000000}"/>
-          </ac:spMkLst>
-        </pc:spChg>
-        <pc:spChg chg="add mod">
-          <ac:chgData name="Allan, John" userId="e8ef1c47-ed91-448d-adaf-3df63196cc6d" providerId="ADAL" clId="{954915EC-4E4C-5938-BB5E-75752EC955AC}" dt="2026-07-17T05:37:02.144" v="192"/>
-          <ac:spMkLst>
-            <pc:docMk/>
-            <pc:sldMk cId="0" sldId="286"/>
-            <ac:spMk id="29" creationId="{42F07AFD-F759-D8F0-91E8-2F6836EEC4C3}"/>
-          </ac:spMkLst>
-        </pc:spChg>
-        <pc:spChg chg="add mod">
-          <ac:chgData name="Allan, John" userId="e8ef1c47-ed91-448d-adaf-3df63196cc6d" providerId="ADAL" clId="{954915EC-4E4C-5938-BB5E-75752EC955AC}" dt="2026-07-17T05:37:02.144" v="192"/>
-          <ac:spMkLst>
-            <pc:docMk/>
-            <pc:sldMk cId="0" sldId="286"/>
-            <ac:spMk id="30" creationId="{2A64C1D0-D684-1FCF-09B3-48ACE01287D0}"/>
-          </ac:spMkLst>
-        </pc:spChg>
-        <pc:spChg chg="add del mod">
-          <ac:chgData name="Allan, John" userId="e8ef1c47-ed91-448d-adaf-3df63196cc6d" providerId="ADAL" clId="{954915EC-4E4C-5938-BB5E-75752EC955AC}" dt="2026-07-17T06:39:54.871" v="627" actId="167"/>
-          <ac:spMkLst>
-            <pc:docMk/>
-            <pc:sldMk cId="0" sldId="286"/>
-            <ac:spMk id="31" creationId="{4BF63834-2AC0-5F6C-B126-02CF00CC16FD}"/>
-          </ac:spMkLst>
-        </pc:spChg>
-        <pc:spChg chg="add mod ord">
-          <ac:chgData name="Allan, John" userId="e8ef1c47-ed91-448d-adaf-3df63196cc6d" providerId="ADAL" clId="{954915EC-4E4C-5938-BB5E-75752EC955AC}" dt="2026-07-17T06:14:24.714" v="534" actId="13244"/>
-          <ac:spMkLst>
-            <pc:docMk/>
-            <pc:sldMk cId="0" sldId="286"/>
-            <ac:spMk id="32" creationId="{A35E760F-49CC-2EBB-145C-AC7DB60B299A}"/>
-          </ac:spMkLst>
-        </pc:spChg>
-      </pc:sldChg>
-      <pc:sldChg chg="modSp mod">
-        <pc:chgData name="Allan, John" userId="e8ef1c47-ed91-448d-adaf-3df63196cc6d" providerId="ADAL" clId="{954915EC-4E4C-5938-BB5E-75752EC955AC}" dt="2026-07-17T06:21:42.427" v="590" actId="13244"/>
-        <pc:sldMkLst>
-          <pc:docMk/>
-          <pc:sldMk cId="0" sldId="287"/>
-        </pc:sldMkLst>
-        <pc:spChg chg="mod ord">
-          <ac:chgData name="Allan, John" userId="e8ef1c47-ed91-448d-adaf-3df63196cc6d" providerId="ADAL" clId="{954915EC-4E4C-5938-BB5E-75752EC955AC}" dt="2026-07-17T06:21:36.896" v="589" actId="13244"/>
-          <ac:spMkLst>
-            <pc:docMk/>
-            <pc:sldMk cId="0" sldId="287"/>
-            <ac:spMk id="5" creationId="{00000000-0000-0000-0000-000000000000}"/>
-          </ac:spMkLst>
-        </pc:spChg>
-        <pc:spChg chg="ord">
-          <ac:chgData name="Allan, John" userId="e8ef1c47-ed91-448d-adaf-3df63196cc6d" providerId="ADAL" clId="{954915EC-4E4C-5938-BB5E-75752EC955AC}" dt="2026-07-17T06:21:42.427" v="590" actId="13244"/>
-          <ac:spMkLst>
-            <pc:docMk/>
-            <pc:sldMk cId="0" sldId="287"/>
-            <ac:spMk id="7" creationId="{00000000-0000-0000-0000-000000000000}"/>
-          </ac:spMkLst>
-        </pc:spChg>
-      </pc:sldChg>
-      <pc:sldChg chg="modSp mod">
-        <pc:chgData name="Allan, John" userId="e8ef1c47-ed91-448d-adaf-3df63196cc6d" providerId="ADAL" clId="{954915EC-4E4C-5938-BB5E-75752EC955AC}" dt="2026-07-17T06:22:10.447" v="592" actId="13244"/>
-        <pc:sldMkLst>
-          <pc:docMk/>
-          <pc:sldMk cId="0" sldId="288"/>
-        </pc:sldMkLst>
-        <pc:spChg chg="ord">
-          <ac:chgData name="Allan, John" userId="e8ef1c47-ed91-448d-adaf-3df63196cc6d" providerId="ADAL" clId="{954915EC-4E4C-5938-BB5E-75752EC955AC}" dt="2026-07-17T06:22:06.710" v="591" actId="13244"/>
-          <ac:spMkLst>
-            <pc:docMk/>
-            <pc:sldMk cId="0" sldId="288"/>
-            <ac:spMk id="4" creationId="{00000000-0000-0000-0000-000000000000}"/>
-          </ac:spMkLst>
-        </pc:spChg>
-        <pc:spChg chg="ord">
-          <ac:chgData name="Allan, John" userId="e8ef1c47-ed91-448d-adaf-3df63196cc6d" providerId="ADAL" clId="{954915EC-4E4C-5938-BB5E-75752EC955AC}" dt="2026-07-17T06:22:10.447" v="592" actId="13244"/>
-          <ac:spMkLst>
-            <pc:docMk/>
-            <pc:sldMk cId="0" sldId="288"/>
-            <ac:spMk id="6" creationId="{00000000-0000-0000-0000-000000000000}"/>
-          </ac:spMkLst>
-        </pc:spChg>
-      </pc:sldChg>
-      <pc:sldChg chg="modSp mod">
-        <pc:chgData name="Allan, John" userId="e8ef1c47-ed91-448d-adaf-3df63196cc6d" providerId="ADAL" clId="{954915EC-4E4C-5938-BB5E-75752EC955AC}" dt="2026-07-17T06:41:12.016" v="645" actId="113"/>
-        <pc:sldMkLst>
-          <pc:docMk/>
-          <pc:sldMk cId="0" sldId="289"/>
-        </pc:sldMkLst>
-        <pc:spChg chg="mod">
-          <ac:chgData name="Allan, John" userId="e8ef1c47-ed91-448d-adaf-3df63196cc6d" providerId="ADAL" clId="{954915EC-4E4C-5938-BB5E-75752EC955AC}" dt="2026-07-17T06:41:07.783" v="643" actId="208"/>
-          <ac:spMkLst>
-            <pc:docMk/>
-            <pc:sldMk cId="0" sldId="289"/>
-            <ac:spMk id="3" creationId="{00000000-0000-0000-0000-000000000000}"/>
-          </ac:spMkLst>
-        </pc:spChg>
-        <pc:spChg chg="mod">
-          <ac:chgData name="Allan, John" userId="e8ef1c47-ed91-448d-adaf-3df63196cc6d" providerId="ADAL" clId="{954915EC-4E4C-5938-BB5E-75752EC955AC}" dt="2026-07-17T06:41:12.016" v="645" actId="113"/>
-          <ac:spMkLst>
-            <pc:docMk/>
-            <pc:sldMk cId="0" sldId="289"/>
-            <ac:spMk id="4" creationId="{00000000-0000-0000-0000-000000000000}"/>
-          </ac:spMkLst>
-        </pc:spChg>
-        <pc:spChg chg="ord">
-          <ac:chgData name="Allan, John" userId="e8ef1c47-ed91-448d-adaf-3df63196cc6d" providerId="ADAL" clId="{954915EC-4E4C-5938-BB5E-75752EC955AC}" dt="2026-07-17T06:24:41.808" v="607" actId="13244"/>
-          <ac:spMkLst>
-            <pc:docMk/>
-            <pc:sldMk cId="0" sldId="289"/>
-            <ac:spMk id="5" creationId="{00000000-0000-0000-0000-000000000000}"/>
-          </ac:spMkLst>
-        </pc:spChg>
-        <pc:spChg chg="ord">
-          <ac:chgData name="Allan, John" userId="e8ef1c47-ed91-448d-adaf-3df63196cc6d" providerId="ADAL" clId="{954915EC-4E4C-5938-BB5E-75752EC955AC}" dt="2026-07-17T06:24:20.880" v="605" actId="13244"/>
-          <ac:spMkLst>
-            <pc:docMk/>
-            <pc:sldMk cId="0" sldId="289"/>
-            <ac:spMk id="7" creationId="{00000000-0000-0000-0000-000000000000}"/>
-          </ac:spMkLst>
-        </pc:spChg>
-      </pc:sldChg>
-      <pc:sldChg chg="modSp mod">
-        <pc:chgData name="Allan, John" userId="e8ef1c47-ed91-448d-adaf-3df63196cc6d" providerId="ADAL" clId="{954915EC-4E4C-5938-BB5E-75752EC955AC}" dt="2026-07-17T06:24:49.845" v="609" actId="13244"/>
-        <pc:sldMkLst>
-          <pc:docMk/>
-          <pc:sldMk cId="0" sldId="290"/>
-        </pc:sldMkLst>
-        <pc:spChg chg="mod">
-          <ac:chgData name="Allan, John" userId="e8ef1c47-ed91-448d-adaf-3df63196cc6d" providerId="ADAL" clId="{954915EC-4E4C-5938-BB5E-75752EC955AC}" dt="2026-07-17T06:04:17.239" v="350" actId="208"/>
-          <ac:spMkLst>
-            <pc:docMk/>
-            <pc:sldMk cId="0" sldId="290"/>
-            <ac:spMk id="2" creationId="{00000000-0000-0000-0000-000000000000}"/>
-          </ac:spMkLst>
-        </pc:spChg>
-        <pc:spChg chg="mod">
-          <ac:chgData name="Allan, John" userId="e8ef1c47-ed91-448d-adaf-3df63196cc6d" providerId="ADAL" clId="{954915EC-4E4C-5938-BB5E-75752EC955AC}" dt="2026-07-17T06:03:49.718" v="345" actId="20577"/>
-          <ac:spMkLst>
-            <pc:docMk/>
-            <pc:sldMk cId="0" sldId="290"/>
-            <ac:spMk id="3" creationId="{00000000-0000-0000-0000-000000000000}"/>
-          </ac:spMkLst>
-        </pc:spChg>
-        <pc:spChg chg="mod ord">
-          <ac:chgData name="Allan, John" userId="e8ef1c47-ed91-448d-adaf-3df63196cc6d" providerId="ADAL" clId="{954915EC-4E4C-5938-BB5E-75752EC955AC}" dt="2026-07-17T06:24:47.488" v="608" actId="13244"/>
-          <ac:spMkLst>
-            <pc:docMk/>
-            <pc:sldMk cId="0" sldId="290"/>
-            <ac:spMk id="4" creationId="{00000000-0000-0000-0000-000000000000}"/>
-          </ac:spMkLst>
-        </pc:spChg>
-        <pc:spChg chg="ord">
-          <ac:chgData name="Allan, John" userId="e8ef1c47-ed91-448d-adaf-3df63196cc6d" providerId="ADAL" clId="{954915EC-4E4C-5938-BB5E-75752EC955AC}" dt="2026-07-17T06:24:49.845" v="609" actId="13244"/>
-          <ac:spMkLst>
-            <pc:docMk/>
-            <pc:sldMk cId="0" sldId="290"/>
-            <ac:spMk id="6" creationId="{00000000-0000-0000-0000-000000000000}"/>
-          </ac:spMkLst>
-        </pc:spChg>
-      </pc:sldChg>
-      <pc:sldChg chg="addSp delSp modSp mod">
-        <pc:chgData name="Allan, John" userId="e8ef1c47-ed91-448d-adaf-3df63196cc6d" providerId="ADAL" clId="{954915EC-4E4C-5938-BB5E-75752EC955AC}" dt="2026-07-17T06:42:01.827" v="650" actId="207"/>
-        <pc:sldMkLst>
-          <pc:docMk/>
-          <pc:sldMk cId="0" sldId="291"/>
-        </pc:sldMkLst>
-        <pc:spChg chg="add del mod ord">
-          <ac:chgData name="Allan, John" userId="e8ef1c47-ed91-448d-adaf-3df63196cc6d" providerId="ADAL" clId="{954915EC-4E4C-5938-BB5E-75752EC955AC}" dt="2026-07-17T06:42:01.827" v="650" actId="207"/>
-          <ac:spMkLst>
-            <pc:docMk/>
-            <pc:sldMk cId="0" sldId="291"/>
-            <ac:spMk id="2" creationId="{00000000-0000-0000-0000-000000000000}"/>
-          </ac:spMkLst>
-        </pc:spChg>
-        <pc:spChg chg="mod ord">
-          <ac:chgData name="Allan, John" userId="e8ef1c47-ed91-448d-adaf-3df63196cc6d" providerId="ADAL" clId="{954915EC-4E4C-5938-BB5E-75752EC955AC}" dt="2026-07-17T06:41:48.913" v="648" actId="208"/>
-          <ac:spMkLst>
-            <pc:docMk/>
-            <pc:sldMk cId="0" sldId="291"/>
-            <ac:spMk id="3" creationId="{00000000-0000-0000-0000-000000000000}"/>
-          </ac:spMkLst>
-        </pc:spChg>
-        <pc:spChg chg="ord">
-          <ac:chgData name="Allan, John" userId="e8ef1c47-ed91-448d-adaf-3df63196cc6d" providerId="ADAL" clId="{954915EC-4E4C-5938-BB5E-75752EC955AC}" dt="2026-07-17T06:24:57.890" v="610" actId="13244"/>
-          <ac:spMkLst>
-            <pc:docMk/>
-            <pc:sldMk cId="0" sldId="291"/>
-            <ac:spMk id="4" creationId="{00000000-0000-0000-0000-000000000000}"/>
-          </ac:spMkLst>
-        </pc:spChg>
-        <pc:spChg chg="ord">
-          <ac:chgData name="Allan, John" userId="e8ef1c47-ed91-448d-adaf-3df63196cc6d" providerId="ADAL" clId="{954915EC-4E4C-5938-BB5E-75752EC955AC}" dt="2026-07-17T06:25:19.909" v="613" actId="13244"/>
-          <ac:spMkLst>
-            <pc:docMk/>
-            <pc:sldMk cId="0" sldId="291"/>
-            <ac:spMk id="6" creationId="{00000000-0000-0000-0000-000000000000}"/>
-          </ac:spMkLst>
-        </pc:spChg>
-        <pc:spChg chg="mod">
-          <ac:chgData name="Allan, John" userId="e8ef1c47-ed91-448d-adaf-3df63196cc6d" providerId="ADAL" clId="{954915EC-4E4C-5938-BB5E-75752EC955AC}" dt="2026-07-17T06:10:07.155" v="467" actId="1076"/>
-          <ac:spMkLst>
-            <pc:docMk/>
-            <pc:sldMk cId="0" sldId="291"/>
-            <ac:spMk id="7" creationId="{00000000-0000-0000-0000-000000000000}"/>
-          </ac:spMkLst>
-        </pc:spChg>
-        <pc:spChg chg="del mod">
-          <ac:chgData name="Allan, John" userId="e8ef1c47-ed91-448d-adaf-3df63196cc6d" providerId="ADAL" clId="{954915EC-4E4C-5938-BB5E-75752EC955AC}" dt="2026-07-17T06:08:30.314" v="407" actId="478"/>
-          <ac:spMkLst>
-            <pc:docMk/>
-            <pc:sldMk cId="0" sldId="291"/>
-            <ac:spMk id="8" creationId="{00000000-0000-0000-0000-000000000000}"/>
-          </ac:spMkLst>
-        </pc:spChg>
-        <pc:spChg chg="mod">
-          <ac:chgData name="Allan, John" userId="e8ef1c47-ed91-448d-adaf-3df63196cc6d" providerId="ADAL" clId="{954915EC-4E4C-5938-BB5E-75752EC955AC}" dt="2026-07-17T06:10:07.155" v="467" actId="1076"/>
-          <ac:spMkLst>
-            <pc:docMk/>
-            <pc:sldMk cId="0" sldId="291"/>
-            <ac:spMk id="9" creationId="{00000000-0000-0000-0000-000000000000}"/>
-          </ac:spMkLst>
-        </pc:spChg>
-        <pc:spChg chg="mod">
-          <ac:chgData name="Allan, John" userId="e8ef1c47-ed91-448d-adaf-3df63196cc6d" providerId="ADAL" clId="{954915EC-4E4C-5938-BB5E-75752EC955AC}" dt="2026-07-17T06:10:07.155" v="467" actId="1076"/>
-          <ac:spMkLst>
-            <pc:docMk/>
-            <pc:sldMk cId="0" sldId="291"/>
-            <ac:spMk id="10" creationId="{00000000-0000-0000-0000-000000000000}"/>
-          </ac:spMkLst>
-        </pc:spChg>
-        <pc:spChg chg="mod">
-          <ac:chgData name="Allan, John" userId="e8ef1c47-ed91-448d-adaf-3df63196cc6d" providerId="ADAL" clId="{954915EC-4E4C-5938-BB5E-75752EC955AC}" dt="2026-07-17T06:10:07.155" v="467" actId="1076"/>
-          <ac:spMkLst>
-            <pc:docMk/>
-            <pc:sldMk cId="0" sldId="291"/>
-            <ac:spMk id="11" creationId="{00000000-0000-0000-0000-000000000000}"/>
-          </ac:spMkLst>
-        </pc:spChg>
-        <pc:spChg chg="mod">
-          <ac:chgData name="Allan, John" userId="e8ef1c47-ed91-448d-adaf-3df63196cc6d" providerId="ADAL" clId="{954915EC-4E4C-5938-BB5E-75752EC955AC}" dt="2026-07-17T06:10:07.155" v="467" actId="1076"/>
-          <ac:spMkLst>
-            <pc:docMk/>
-            <pc:sldMk cId="0" sldId="291"/>
-            <ac:spMk id="12" creationId="{00000000-0000-0000-0000-000000000000}"/>
-          </ac:spMkLst>
-        </pc:spChg>
-        <pc:spChg chg="mod">
-          <ac:chgData name="Allan, John" userId="e8ef1c47-ed91-448d-adaf-3df63196cc6d" providerId="ADAL" clId="{954915EC-4E4C-5938-BB5E-75752EC955AC}" dt="2026-07-17T06:10:07.155" v="467" actId="1076"/>
-          <ac:spMkLst>
-            <pc:docMk/>
-            <pc:sldMk cId="0" sldId="291"/>
-            <ac:spMk id="13" creationId="{00000000-0000-0000-0000-000000000000}"/>
-          </ac:spMkLst>
-        </pc:spChg>
-        <pc:spChg chg="mod">
-          <ac:chgData name="Allan, John" userId="e8ef1c47-ed91-448d-adaf-3df63196cc6d" providerId="ADAL" clId="{954915EC-4E4C-5938-BB5E-75752EC955AC}" dt="2026-07-17T06:08:41.879" v="431" actId="1076"/>
-          <ac:spMkLst>
-            <pc:docMk/>
-            <pc:sldMk cId="0" sldId="291"/>
-            <ac:spMk id="14" creationId="{00000000-0000-0000-0000-000000000000}"/>
-          </ac:spMkLst>
-        </pc:spChg>
-        <pc:spChg chg="mod">
-          <ac:chgData name="Allan, John" userId="e8ef1c47-ed91-448d-adaf-3df63196cc6d" providerId="ADAL" clId="{954915EC-4E4C-5938-BB5E-75752EC955AC}" dt="2026-07-17T06:08:41.879" v="431" actId="1076"/>
-          <ac:spMkLst>
-            <pc:docMk/>
-            <pc:sldMk cId="0" sldId="291"/>
-            <ac:spMk id="15" creationId="{00000000-0000-0000-0000-000000000000}"/>
-          </ac:spMkLst>
-        </pc:spChg>
-        <pc:spChg chg="mod">
-          <ac:chgData name="Allan, John" userId="e8ef1c47-ed91-448d-adaf-3df63196cc6d" providerId="ADAL" clId="{954915EC-4E4C-5938-BB5E-75752EC955AC}" dt="2026-07-17T06:06:23.495" v="369" actId="108"/>
-          <ac:spMkLst>
-            <pc:docMk/>
-            <pc:sldMk cId="0" sldId="291"/>
-            <ac:spMk id="16" creationId="{00000000-0000-0000-0000-000000000000}"/>
-          </ac:spMkLst>
-        </pc:spChg>
-        <pc:spChg chg="mod">
-          <ac:chgData name="Allan, John" userId="e8ef1c47-ed91-448d-adaf-3df63196cc6d" providerId="ADAL" clId="{954915EC-4E4C-5938-BB5E-75752EC955AC}" dt="2026-07-17T05:16:47.641" v="145" actId="20577"/>
-          <ac:spMkLst>
-            <pc:docMk/>
-            <pc:sldMk cId="0" sldId="291"/>
-            <ac:spMk id="17" creationId="{00000000-0000-0000-0000-000000000000}"/>
-          </ac:spMkLst>
-        </pc:spChg>
-        <pc:spChg chg="mod ord">
-          <ac:chgData name="Allan, John" userId="e8ef1c47-ed91-448d-adaf-3df63196cc6d" providerId="ADAL" clId="{954915EC-4E4C-5938-BB5E-75752EC955AC}" dt="2026-07-17T06:25:24.450" v="614" actId="13244"/>
-          <ac:spMkLst>
-            <pc:docMk/>
-            <pc:sldMk cId="0" sldId="291"/>
-            <ac:spMk id="18" creationId="{00000000-0000-0000-0000-000000000000}"/>
-          </ac:spMkLst>
-        </pc:spChg>
-        <pc:spChg chg="ord">
-          <ac:chgData name="Allan, John" userId="e8ef1c47-ed91-448d-adaf-3df63196cc6d" providerId="ADAL" clId="{954915EC-4E4C-5938-BB5E-75752EC955AC}" dt="2026-07-17T06:25:35.257" v="615" actId="13244"/>
-          <ac:spMkLst>
-            <pc:docMk/>
-            <pc:sldMk cId="0" sldId="291"/>
-            <ac:spMk id="19" creationId="{B2515E2D-BE84-6770-0F27-0C567367D8B4}"/>
-          </ac:spMkLst>
-        </pc:spChg>
-        <pc:spChg chg="add del mod">
-          <ac:chgData name="Allan, John" userId="e8ef1c47-ed91-448d-adaf-3df63196cc6d" providerId="ADAL" clId="{954915EC-4E4C-5938-BB5E-75752EC955AC}" dt="2026-07-17T06:07:07.290" v="381" actId="478"/>
-          <ac:spMkLst>
-            <pc:docMk/>
-            <pc:sldMk cId="0" sldId="291"/>
-            <ac:spMk id="20" creationId="{36F626C4-2671-6964-1223-732684F0C0F6}"/>
-          </ac:spMkLst>
-        </pc:spChg>
-        <pc:spChg chg="add mod">
-          <ac:chgData name="Allan, John" userId="e8ef1c47-ed91-448d-adaf-3df63196cc6d" providerId="ADAL" clId="{954915EC-4E4C-5938-BB5E-75752EC955AC}" dt="2026-07-17T05:17:05.160" v="148" actId="1076"/>
-          <ac:spMkLst>
-            <pc:docMk/>
-            <pc:sldMk cId="0" sldId="291"/>
-            <ac:spMk id="20" creationId="{FF1D3BE8-5F51-7201-F804-1532B9815ED7}"/>
-          </ac:spMkLst>
-        </pc:spChg>
-        <pc:spChg chg="add del mod">
-          <ac:chgData name="Allan, John" userId="e8ef1c47-ed91-448d-adaf-3df63196cc6d" providerId="ADAL" clId="{954915EC-4E4C-5938-BB5E-75752EC955AC}" dt="2026-07-17T06:06:30.080" v="371" actId="21"/>
-          <ac:spMkLst>
-            <pc:docMk/>
-            <pc:sldMk cId="0" sldId="291"/>
-            <ac:spMk id="21" creationId="{13CB2087-0871-AEA3-C65A-5F5CC967DE31}"/>
-          </ac:spMkLst>
-        </pc:spChg>
-        <pc:spChg chg="add del mod">
-          <ac:chgData name="Allan, John" userId="e8ef1c47-ed91-448d-adaf-3df63196cc6d" providerId="ADAL" clId="{954915EC-4E4C-5938-BB5E-75752EC955AC}" dt="2026-07-17T06:07:08.268" v="382" actId="478"/>
-          <ac:spMkLst>
-            <pc:docMk/>
-            <pc:sldMk cId="0" sldId="291"/>
-            <ac:spMk id="22" creationId="{01AE9B01-79D9-4A26-B2B2-28DC8F24495D}"/>
-          </ac:spMkLst>
-        </pc:spChg>
-        <pc:spChg chg="add mod">
-          <ac:chgData name="Allan, John" userId="e8ef1c47-ed91-448d-adaf-3df63196cc6d" providerId="ADAL" clId="{954915EC-4E4C-5938-BB5E-75752EC955AC}" dt="2026-07-17T06:10:07.155" v="467" actId="1076"/>
-          <ac:spMkLst>
-            <pc:docMk/>
-            <pc:sldMk cId="0" sldId="291"/>
-            <ac:spMk id="23" creationId="{A0406736-BDF9-1E0C-F523-1E3F22CC7006}"/>
-          </ac:spMkLst>
-        </pc:spChg>
-        <pc:spChg chg="add mod">
-          <ac:chgData name="Allan, John" userId="e8ef1c47-ed91-448d-adaf-3df63196cc6d" providerId="ADAL" clId="{954915EC-4E4C-5938-BB5E-75752EC955AC}" dt="2026-07-17T06:10:07.155" v="467" actId="1076"/>
-          <ac:spMkLst>
-            <pc:docMk/>
-            <pc:sldMk cId="0" sldId="291"/>
-            <ac:spMk id="24" creationId="{C1443E81-F3B8-056F-0EE5-8B99BE40C61F}"/>
-          </ac:spMkLst>
-        </pc:spChg>
-        <pc:spChg chg="add mod">
-          <ac:chgData name="Allan, John" userId="e8ef1c47-ed91-448d-adaf-3df63196cc6d" providerId="ADAL" clId="{954915EC-4E4C-5938-BB5E-75752EC955AC}" dt="2026-07-17T06:10:07.155" v="467" actId="1076"/>
-          <ac:spMkLst>
-            <pc:docMk/>
-            <pc:sldMk cId="0" sldId="291"/>
-            <ac:spMk id="25" creationId="{5EB8DFE1-1FAF-0F2B-41AD-BD07DF24E4AA}"/>
-          </ac:spMkLst>
-        </pc:spChg>
-        <pc:spChg chg="add mod">
-          <ac:chgData name="Allan, John" userId="e8ef1c47-ed91-448d-adaf-3df63196cc6d" providerId="ADAL" clId="{954915EC-4E4C-5938-BB5E-75752EC955AC}" dt="2026-07-17T06:10:23.993" v="489" actId="20577"/>
-          <ac:spMkLst>
-            <pc:docMk/>
-            <pc:sldMk cId="0" sldId="291"/>
-            <ac:spMk id="26" creationId="{DBFE81A8-42AE-F2FC-A409-ECDF42AB6B41}"/>
-          </ac:spMkLst>
-        </pc:spChg>
-        <pc:spChg chg="add mod ord">
-          <ac:chgData name="Allan, John" userId="e8ef1c47-ed91-448d-adaf-3df63196cc6d" providerId="ADAL" clId="{954915EC-4E4C-5938-BB5E-75752EC955AC}" dt="2026-07-17T06:26:12.655" v="620" actId="13244"/>
-          <ac:spMkLst>
-            <pc:docMk/>
-            <pc:sldMk cId="0" sldId="291"/>
-            <ac:spMk id="27" creationId="{6072817F-6AFF-1E4D-547A-630355B8C508}"/>
-          </ac:spMkLst>
-        </pc:spChg>
-      </pc:sldChg>
-      <pc:sldChg chg="addSp delSp modSp add del mod">
-        <pc:chgData name="Allan, John" userId="e8ef1c47-ed91-448d-adaf-3df63196cc6d" providerId="ADAL" clId="{954915EC-4E4C-5938-BB5E-75752EC955AC}" dt="2026-07-17T05:15:36.617" v="122" actId="2696"/>
-        <pc:sldMkLst>
-          <pc:docMk/>
-          <pc:sldMk cId="1559963368" sldId="292"/>
-        </pc:sldMkLst>
-        <pc:spChg chg="del">
-          <ac:chgData name="Allan, John" userId="e8ef1c47-ed91-448d-adaf-3df63196cc6d" providerId="ADAL" clId="{954915EC-4E4C-5938-BB5E-75752EC955AC}" dt="2026-07-17T04:48:45.011" v="76" actId="478"/>
-          <ac:spMkLst>
-            <pc:docMk/>
-            <pc:sldMk cId="1559963368" sldId="292"/>
-            <ac:spMk id="3" creationId="{A6B863C8-5155-3EB5-70DC-35BF74E2DDE7}"/>
-          </ac:spMkLst>
-        </pc:spChg>
-        <pc:spChg chg="del">
-          <ac:chgData name="Allan, John" userId="e8ef1c47-ed91-448d-adaf-3df63196cc6d" providerId="ADAL" clId="{954915EC-4E4C-5938-BB5E-75752EC955AC}" dt="2026-07-17T04:49:29.523" v="82" actId="478"/>
-          <ac:spMkLst>
-            <pc:docMk/>
-            <pc:sldMk cId="1559963368" sldId="292"/>
-            <ac:spMk id="4" creationId="{E1021208-CA21-C129-2FF1-A8CD17ABEDC3}"/>
-          </ac:spMkLst>
-        </pc:spChg>
-        <pc:spChg chg="add mod">
-          <ac:chgData name="Allan, John" userId="e8ef1c47-ed91-448d-adaf-3df63196cc6d" providerId="ADAL" clId="{954915EC-4E4C-5938-BB5E-75752EC955AC}" dt="2026-07-17T04:48:45.399" v="77"/>
-          <ac:spMkLst>
-            <pc:docMk/>
-            <pc:sldMk cId="1559963368" sldId="292"/>
-            <ac:spMk id="26" creationId="{72F54418-DDC8-78C2-1724-B8808C9993F1}"/>
-          </ac:spMkLst>
-        </pc:spChg>
-        <pc:spChg chg="add mod">
-          <ac:chgData name="Allan, John" userId="e8ef1c47-ed91-448d-adaf-3df63196cc6d" providerId="ADAL" clId="{954915EC-4E4C-5938-BB5E-75752EC955AC}" dt="2026-07-17T04:48:45.399" v="77"/>
-          <ac:spMkLst>
-            <pc:docMk/>
-            <pc:sldMk cId="1559963368" sldId="292"/>
-            <ac:spMk id="27" creationId="{4C35CA80-DC82-6CC2-0702-8D4F3416A2FC}"/>
-          </ac:spMkLst>
-        </pc:spChg>
-        <pc:spChg chg="add mod">
-          <ac:chgData name="Allan, John" userId="e8ef1c47-ed91-448d-adaf-3df63196cc6d" providerId="ADAL" clId="{954915EC-4E4C-5938-BB5E-75752EC955AC}" dt="2026-07-17T04:49:07.806" v="78"/>
-          <ac:spMkLst>
-            <pc:docMk/>
-            <pc:sldMk cId="1559963368" sldId="292"/>
-            <ac:spMk id="28" creationId="{AA800037-3719-54A9-E194-13855A60029E}"/>
-          </ac:spMkLst>
-        </pc:spChg>
-        <pc:spChg chg="add mod">
-          <ac:chgData name="Allan, John" userId="e8ef1c47-ed91-448d-adaf-3df63196cc6d" providerId="ADAL" clId="{954915EC-4E4C-5938-BB5E-75752EC955AC}" dt="2026-07-17T04:49:07.806" v="78"/>
-          <ac:spMkLst>
-            <pc:docMk/>
-            <pc:sldMk cId="1559963368" sldId="292"/>
-            <ac:spMk id="29" creationId="{78038F30-64AE-CB31-5076-7B045E8E7429}"/>
-          </ac:spMkLst>
-        </pc:spChg>
-        <pc:spChg chg="add del mod">
-          <ac:chgData name="Allan, John" userId="e8ef1c47-ed91-448d-adaf-3df63196cc6d" providerId="ADAL" clId="{954915EC-4E4C-5938-BB5E-75752EC955AC}" dt="2026-07-17T04:49:29.523" v="82" actId="478"/>
-          <ac:spMkLst>
-            <pc:docMk/>
-            <pc:sldMk cId="1559963368" sldId="292"/>
-            <ac:spMk id="30" creationId="{4F155B25-8FD6-B526-5650-832AC25AAD86}"/>
-          </ac:spMkLst>
-        </pc:spChg>
-        <pc:spChg chg="add del mod">
-          <ac:chgData name="Allan, John" userId="e8ef1c47-ed91-448d-adaf-3df63196cc6d" providerId="ADAL" clId="{954915EC-4E4C-5938-BB5E-75752EC955AC}" dt="2026-07-17T04:49:29.523" v="82" actId="478"/>
-          <ac:spMkLst>
-            <pc:docMk/>
-            <pc:sldMk cId="1559963368" sldId="292"/>
-            <ac:spMk id="31" creationId="{3D2C69A2-0B59-E44B-8509-ADB0528577AF}"/>
-          </ac:spMkLst>
-        </pc:spChg>
-        <pc:spChg chg="add mod">
-          <ac:chgData name="Allan, John" userId="e8ef1c47-ed91-448d-adaf-3df63196cc6d" providerId="ADAL" clId="{954915EC-4E4C-5938-BB5E-75752EC955AC}" dt="2026-07-17T04:49:24.370" v="81"/>
-          <ac:spMkLst>
-            <pc:docMk/>
-            <pc:sldMk cId="1559963368" sldId="292"/>
-            <ac:spMk id="32" creationId="{AFF87508-B675-0D52-CBBA-EE3C7716FDE3}"/>
-          </ac:spMkLst>
-        </pc:spChg>
-        <pc:spChg chg="add mod">
-          <ac:chgData name="Allan, John" userId="e8ef1c47-ed91-448d-adaf-3df63196cc6d" providerId="ADAL" clId="{954915EC-4E4C-5938-BB5E-75752EC955AC}" dt="2026-07-17T04:49:24.370" v="81"/>
-          <ac:spMkLst>
-            <pc:docMk/>
-            <pc:sldMk cId="1559963368" sldId="292"/>
-            <ac:spMk id="33" creationId="{D14EAB4D-9305-DB07-3596-CD92A0EBFA76}"/>
-          </ac:spMkLst>
-        </pc:spChg>
-        <pc:spChg chg="add mod">
-          <ac:chgData name="Allan, John" userId="e8ef1c47-ed91-448d-adaf-3df63196cc6d" providerId="ADAL" clId="{954915EC-4E4C-5938-BB5E-75752EC955AC}" dt="2026-07-17T04:49:30.421" v="83"/>
-          <ac:spMkLst>
-            <pc:docMk/>
-            <pc:sldMk cId="1559963368" sldId="292"/>
-            <ac:spMk id="34" creationId="{7739E1EE-4BCB-33BC-E34E-A76E62488179}"/>
-          </ac:spMkLst>
-        </pc:spChg>
-        <pc:spChg chg="add mod">
-          <ac:chgData name="Allan, John" userId="e8ef1c47-ed91-448d-adaf-3df63196cc6d" providerId="ADAL" clId="{954915EC-4E4C-5938-BB5E-75752EC955AC}" dt="2026-07-17T04:49:30.421" v="83"/>
-          <ac:spMkLst>
-            <pc:docMk/>
-            <pc:sldMk cId="1559963368" sldId="292"/>
-            <ac:spMk id="35" creationId="{B008FC00-93D6-6FFF-22B1-0E7E71A33E5B}"/>
-          </ac:spMkLst>
-        </pc:spChg>
-      </pc:sldChg>
-      <pc:sldChg chg="modSp add mod ord setBg">
-        <pc:chgData name="Allan, John" userId="e8ef1c47-ed91-448d-adaf-3df63196cc6d" providerId="ADAL" clId="{954915EC-4E4C-5938-BB5E-75752EC955AC}" dt="2026-07-17T06:14:38.246" v="536" actId="13244"/>
-        <pc:sldMkLst>
-          <pc:docMk/>
-          <pc:sldMk cId="0" sldId="293"/>
-        </pc:sldMkLst>
-        <pc:spChg chg="mod">
-          <ac:chgData name="Allan, John" userId="e8ef1c47-ed91-448d-adaf-3df63196cc6d" providerId="ADAL" clId="{954915EC-4E4C-5938-BB5E-75752EC955AC}" dt="2026-07-17T06:12:01.456" v="492" actId="962"/>
-          <ac:spMkLst>
-            <pc:docMk/>
-            <pc:sldMk cId="0" sldId="293"/>
-            <ac:spMk id="2" creationId="{00000000-0000-0000-0000-000000000000}"/>
-          </ac:spMkLst>
-        </pc:spChg>
-        <pc:spChg chg="mod">
-          <ac:chgData name="Allan, John" userId="e8ef1c47-ed91-448d-adaf-3df63196cc6d" providerId="ADAL" clId="{954915EC-4E4C-5938-BB5E-75752EC955AC}" dt="2026-07-17T06:12:01.458" v="493" actId="962"/>
-          <ac:spMkLst>
-            <pc:docMk/>
-            <pc:sldMk cId="0" sldId="293"/>
-            <ac:spMk id="3" creationId="{00000000-0000-0000-0000-000000000000}"/>
-          </ac:spMkLst>
-        </pc:spChg>
-        <pc:spChg chg="mod">
-          <ac:chgData name="Allan, John" userId="e8ef1c47-ed91-448d-adaf-3df63196cc6d" providerId="ADAL" clId="{954915EC-4E4C-5938-BB5E-75752EC955AC}" dt="2026-07-17T05:15:50.208" v="134" actId="20577"/>
-          <ac:spMkLst>
-            <pc:docMk/>
-            <pc:sldMk cId="0" sldId="293"/>
-            <ac:spMk id="4" creationId="{00000000-0000-0000-0000-000000000000}"/>
-          </ac:spMkLst>
-        </pc:spChg>
-        <pc:spChg chg="mod ord">
-          <ac:chgData name="Allan, John" userId="e8ef1c47-ed91-448d-adaf-3df63196cc6d" providerId="ADAL" clId="{954915EC-4E4C-5938-BB5E-75752EC955AC}" dt="2026-07-17T06:14:34.749" v="535" actId="13244"/>
-          <ac:spMkLst>
-            <pc:docMk/>
-            <pc:sldMk cId="0" sldId="293"/>
-            <ac:spMk id="5" creationId="{00000000-0000-0000-0000-000000000000}"/>
-          </ac:spMkLst>
-        </pc:spChg>
-        <pc:spChg chg="ord">
-          <ac:chgData name="Allan, John" userId="e8ef1c47-ed91-448d-adaf-3df63196cc6d" providerId="ADAL" clId="{954915EC-4E4C-5938-BB5E-75752EC955AC}" dt="2026-07-17T06:14:38.246" v="536" actId="13244"/>
-          <ac:spMkLst>
-            <pc:docMk/>
-            <pc:sldMk cId="0" sldId="293"/>
-            <ac:spMk id="7" creationId="{00000000-0000-0000-0000-000000000000}"/>
-          </ac:spMkLst>
-        </pc:spChg>
-        <pc:spChg chg="mod">
-          <ac:chgData name="Allan, John" userId="e8ef1c47-ed91-448d-adaf-3df63196cc6d" providerId="ADAL" clId="{954915EC-4E4C-5938-BB5E-75752EC955AC}" dt="2026-07-17T06:12:01.460" v="494" actId="962"/>
-          <ac:spMkLst>
-            <pc:docMk/>
-            <pc:sldMk cId="0" sldId="293"/>
-            <ac:spMk id="8" creationId="{00000000-0000-0000-0000-000000000000}"/>
-          </ac:spMkLst>
-        </pc:spChg>
-        <pc:spChg chg="mod">
-          <ac:chgData name="Allan, John" userId="e8ef1c47-ed91-448d-adaf-3df63196cc6d" providerId="ADAL" clId="{954915EC-4E4C-5938-BB5E-75752EC955AC}" dt="2026-07-17T06:12:01.463" v="495" actId="962"/>
-          <ac:spMkLst>
-            <pc:docMk/>
-            <pc:sldMk cId="0" sldId="293"/>
-            <ac:spMk id="9" creationId="{00000000-0000-0000-0000-000000000000}"/>
-          </ac:spMkLst>
-        </pc:spChg>
-        <pc:spChg chg="mod">
-          <ac:chgData name="Allan, John" userId="e8ef1c47-ed91-448d-adaf-3df63196cc6d" providerId="ADAL" clId="{954915EC-4E4C-5938-BB5E-75752EC955AC}" dt="2026-07-17T06:12:01.465" v="496" actId="962"/>
-          <ac:spMkLst>
-            <pc:docMk/>
-            <pc:sldMk cId="0" sldId="293"/>
-            <ac:spMk id="12" creationId="{00000000-0000-0000-0000-000000000000}"/>
-          </ac:spMkLst>
-        </pc:spChg>
-        <pc:spChg chg="mod">
-          <ac:chgData name="Allan, John" userId="e8ef1c47-ed91-448d-adaf-3df63196cc6d" providerId="ADAL" clId="{954915EC-4E4C-5938-BB5E-75752EC955AC}" dt="2026-07-17T06:12:01.467" v="497" actId="962"/>
-          <ac:spMkLst>
-            <pc:docMk/>
-            <pc:sldMk cId="0" sldId="293"/>
-            <ac:spMk id="13" creationId="{00000000-0000-0000-0000-000000000000}"/>
-          </ac:spMkLst>
-        </pc:spChg>
-        <pc:spChg chg="mod">
-          <ac:chgData name="Allan, John" userId="e8ef1c47-ed91-448d-adaf-3df63196cc6d" providerId="ADAL" clId="{954915EC-4E4C-5938-BB5E-75752EC955AC}" dt="2026-07-17T06:12:01.468" v="498" actId="962"/>
-          <ac:spMkLst>
-            <pc:docMk/>
-            <pc:sldMk cId="0" sldId="293"/>
-            <ac:spMk id="16" creationId="{00000000-0000-0000-0000-000000000000}"/>
-          </ac:spMkLst>
-        </pc:spChg>
-        <pc:spChg chg="mod">
-          <ac:chgData name="Allan, John" userId="e8ef1c47-ed91-448d-adaf-3df63196cc6d" providerId="ADAL" clId="{954915EC-4E4C-5938-BB5E-75752EC955AC}" dt="2026-07-17T06:12:01.470" v="499" actId="962"/>
-          <ac:spMkLst>
-            <pc:docMk/>
-            <pc:sldMk cId="0" sldId="293"/>
-            <ac:spMk id="17" creationId="{00000000-0000-0000-0000-000000000000}"/>
-          </ac:spMkLst>
-        </pc:spChg>
-        <pc:spChg chg="mod">
-          <ac:chgData name="Allan, John" userId="e8ef1c47-ed91-448d-adaf-3df63196cc6d" providerId="ADAL" clId="{954915EC-4E4C-5938-BB5E-75752EC955AC}" dt="2026-07-17T06:12:01.472" v="500" actId="962"/>
-          <ac:spMkLst>
-            <pc:docMk/>
-            <pc:sldMk cId="0" sldId="293"/>
-            <ac:spMk id="20" creationId="{00000000-0000-0000-0000-000000000000}"/>
-          </ac:spMkLst>
-        </pc:spChg>
-        <pc:spChg chg="mod">
-          <ac:chgData name="Allan, John" userId="e8ef1c47-ed91-448d-adaf-3df63196cc6d" providerId="ADAL" clId="{954915EC-4E4C-5938-BB5E-75752EC955AC}" dt="2026-07-17T06:12:01.473" v="501" actId="962"/>
-          <ac:spMkLst>
-            <pc:docMk/>
-            <pc:sldMk cId="0" sldId="293"/>
-            <ac:spMk id="21" creationId="{00000000-0000-0000-0000-000000000000}"/>
-          </ac:spMkLst>
-        </pc:spChg>
-        <pc:spChg chg="mod">
-          <ac:chgData name="Allan, John" userId="e8ef1c47-ed91-448d-adaf-3df63196cc6d" providerId="ADAL" clId="{954915EC-4E4C-5938-BB5E-75752EC955AC}" dt="2026-07-17T05:15:35.453" v="120" actId="27636"/>
-          <ac:spMkLst>
-            <pc:docMk/>
-            <pc:sldMk cId="0" sldId="293"/>
-            <ac:spMk id="22" creationId="{00000000-0000-0000-0000-000000000000}"/>
-          </ac:spMkLst>
-        </pc:spChg>
-        <pc:spChg chg="mod">
-          <ac:chgData name="Allan, John" userId="e8ef1c47-ed91-448d-adaf-3df63196cc6d" providerId="ADAL" clId="{954915EC-4E4C-5938-BB5E-75752EC955AC}" dt="2026-07-17T06:12:01.474" v="502" actId="962"/>
-          <ac:spMkLst>
-            <pc:docMk/>
-            <pc:sldMk cId="0" sldId="293"/>
-            <ac:spMk id="24" creationId="{00000000-0000-0000-0000-000000000000}"/>
-          </ac:spMkLst>
-        </pc:spChg>
-        <pc:spChg chg="mod">
-          <ac:chgData name="Allan, John" userId="e8ef1c47-ed91-448d-adaf-3df63196cc6d" providerId="ADAL" clId="{954915EC-4E4C-5938-BB5E-75752EC955AC}" dt="2026-07-17T05:15:35.453" v="121" actId="27636"/>
-          <ac:spMkLst>
-            <pc:docMk/>
-            <pc:sldMk cId="0" sldId="293"/>
-            <ac:spMk id="25" creationId="{00000000-0000-0000-0000-000000000000}"/>
-          </ac:spMkLst>
-        </pc:spChg>
-        <pc:spChg chg="mod">
-          <ac:chgData name="Allan, John" userId="e8ef1c47-ed91-448d-adaf-3df63196cc6d" providerId="ADAL" clId="{954915EC-4E4C-5938-BB5E-75752EC955AC}" dt="2026-07-17T06:12:01.476" v="503" actId="962"/>
-          <ac:spMkLst>
-            <pc:docMk/>
-            <pc:sldMk cId="0" sldId="293"/>
-            <ac:spMk id="26" creationId="{00000000-0000-0000-0000-000000000000}"/>
-          </ac:spMkLst>
-        </pc:spChg>
-      </pc:sldChg>
-      <pc:sldChg chg="add del">
-        <pc:chgData name="Allan, John" userId="e8ef1c47-ed91-448d-adaf-3df63196cc6d" providerId="ADAL" clId="{954915EC-4E4C-5938-BB5E-75752EC955AC}" dt="2026-07-17T05:58:27.045" v="267" actId="2696"/>
-        <pc:sldMkLst>
-          <pc:docMk/>
-          <pc:sldMk cId="2287679792" sldId="294"/>
-        </pc:sldMkLst>
-      </pc:sldChg>
-    </pc:docChg>
-  </pc:docChgLst>
-</pc:chgInfo>
 </file>
 
 <file path=ppt/notesMasters/notesMaster1.xml><?xml version="1.0" encoding="utf-8"?>
@@ -5499,7 +3508,7 @@
         </p:nvSpPr>
         <p:spPr>
           <a:xfrm>
-            <a:off x="768096" y="2395728"/>
+            <a:off x="731520" y="1755648"/>
             <a:ext cx="7315200" cy="594360"/>
           </a:xfrm>
           <a:prstGeom prst="rect">
@@ -5572,8 +3581,52 @@
       </p:sp>
       <p:sp>
         <p:nvSpPr>
-          <p:cNvPr id="8" name="Shape 6">
+          <p:cNvPr id="2" name="Text 0"/>
+          <p:cNvSpPr/>
+          <p:nvPr/>
+        </p:nvSpPr>
+        <p:spPr>
+          <a:xfrm>
+            <a:off x="594360" y="6510528"/>
+            <a:ext cx="5943600" cy="164592"/>
+          </a:xfrm>
+          <a:prstGeom prst="rect">
+            <a:avLst/>
+          </a:prstGeom>
+          <a:noFill/>
+          <a:ln/>
+        </p:spPr>
+        <p:txBody>
+          <a:bodyPr wrap="square" lIns="0" tIns="0" rIns="0" bIns="0" rtlCol="0" anchor="ctr">
+            <a:normAutofit/>
+          </a:bodyPr>
+          <a:lstStyle/>
+          <a:p>
+            <a:pPr marL="0" indent="0">
+              <a:buNone/>
+            </a:pPr>
+            <a:r>
+              <a:rPr lang="en-US" sz="800" dirty="0">
+                <a:solidFill>
+                  <a:srgbClr val="BFC9DB"/>
+                </a:solidFill>
+                <a:latin typeface="Aptos" pitchFamily="34" charset="0"/>
+                <a:ea typeface="Aptos" pitchFamily="34" charset="-122"/>
+                <a:cs typeface="Aptos" pitchFamily="34" charset="-120"/>
+              </a:rPr>
+              <a:t>Hillsborough College  |  Summer Institute 2026</a:t>
+            </a:r>
+            <a:endParaRPr lang="en-US" sz="800" dirty="0"/>
+          </a:p>
+        </p:txBody>
+      </p:sp>
+      <p:sp>
+        <p:nvSpPr>
+          <p:cNvPr id="25" name="Rounded Rectangle 24">
             <a:extLst>
+              <a:ext uri="{FF2B5EF4-FFF2-40B4-BE49-F238E27FC236}">
+                <a16:creationId xmlns:a16="http://schemas.microsoft.com/office/drawing/2014/main" id="{433C50DF-41AD-96DD-AE5C-4953FA045303}"/>
+              </a:ext>
               <a:ext uri="{C183D7F6-B498-43B3-948B-1728B52AA6E4}">
                 <adec:decorative xmlns:adec="http://schemas.microsoft.com/office/drawing/2017/decorative" val="1"/>
               </a:ext>
@@ -5584,159 +3637,51 @@
         </p:nvSpPr>
         <p:spPr>
           <a:xfrm>
-            <a:off x="768096" y="3246120"/>
-            <a:ext cx="3291840" cy="0"/>
-          </a:xfrm>
-          <a:prstGeom prst="line">
-            <a:avLst/>
-          </a:prstGeom>
-          <a:noFill/>
-          <a:ln w="50800">
-            <a:solidFill>
-              <a:srgbClr val="149966"/>
-            </a:solidFill>
-            <a:prstDash val="solid"/>
-            <a:headEnd type="none"/>
-            <a:tailEnd type="none"/>
-          </a:ln>
-        </p:spPr>
-        <p:txBody>
-          <a:bodyPr/>
-          <a:lstStyle/>
-          <a:p>
-            <a:endParaRPr lang="en-US"/>
-          </a:p>
-        </p:txBody>
-      </p:sp>
-      <p:sp>
-        <p:nvSpPr>
-          <p:cNvPr id="9" name="Text 7"/>
-          <p:cNvSpPr/>
-          <p:nvPr/>
-        </p:nvSpPr>
-        <p:spPr>
-          <a:xfrm>
-            <a:off x="768096" y="3566160"/>
-            <a:ext cx="6766560" cy="457200"/>
-          </a:xfrm>
-          <a:prstGeom prst="rect">
-            <a:avLst/>
-          </a:prstGeom>
-          <a:noFill/>
-          <a:ln/>
-        </p:spPr>
-        <p:txBody>
-          <a:bodyPr wrap="square" lIns="0" tIns="0" rIns="0" bIns="0" rtlCol="0" anchor="ctr">
-            <a:normAutofit/>
-          </a:bodyPr>
-          <a:lstStyle/>
-          <a:p>
-            <a:pPr marL="0" indent="0">
-              <a:buNone/>
-            </a:pPr>
-            <a:r>
-              <a:rPr lang="en-US" sz="1800" dirty="0">
-                <a:solidFill>
-                  <a:srgbClr val="FFFFFF"/>
-                </a:solidFill>
-                <a:latin typeface="Aptos" pitchFamily="34" charset="0"/>
-                <a:ea typeface="Aptos" pitchFamily="34" charset="-122"/>
-                <a:cs typeface="Aptos" pitchFamily="34" charset="-120"/>
-              </a:rPr>
-              <a:t>A design-first workflow</a:t>
-            </a:r>
-            <a:endParaRPr lang="en-US" sz="1800" dirty="0"/>
-          </a:p>
-        </p:txBody>
-      </p:sp>
-      <p:sp>
-        <p:nvSpPr>
-          <p:cNvPr id="10" name="Text 8"/>
-          <p:cNvSpPr/>
-          <p:nvPr/>
-        </p:nvSpPr>
-        <p:spPr>
-          <a:xfrm>
-            <a:off x="768096" y="4315968"/>
-            <a:ext cx="4846320" cy="329184"/>
-          </a:xfrm>
-          <a:prstGeom prst="rect">
-            <a:avLst/>
-          </a:prstGeom>
-          <a:noFill/>
-          <a:ln/>
-        </p:spPr>
-        <p:txBody>
-          <a:bodyPr wrap="square" lIns="0" tIns="0" rIns="0" bIns="0" rtlCol="0" anchor="ctr">
-            <a:normAutofit/>
-          </a:bodyPr>
-          <a:lstStyle/>
-          <a:p>
-            <a:pPr marL="0" indent="0">
-              <a:buNone/>
-            </a:pPr>
-            <a:r>
-              <a:rPr lang="en-US" sz="1300" b="1" dirty="0">
-                <a:solidFill>
-                  <a:srgbClr val="D5B979"/>
-                </a:solidFill>
-                <a:latin typeface="Aptos" pitchFamily="34" charset="0"/>
-                <a:ea typeface="Aptos" pitchFamily="34" charset="-122"/>
-                <a:cs typeface="Aptos" pitchFamily="34" charset="-120"/>
-              </a:rPr>
-              <a:t>Canvas LMS  +  Microsoft Copilot</a:t>
-            </a:r>
-            <a:endParaRPr lang="en-US" sz="1300" dirty="0"/>
-          </a:p>
-        </p:txBody>
-      </p:sp>
-      <p:sp>
-        <p:nvSpPr>
-          <p:cNvPr id="11" name="Text 9"/>
-          <p:cNvSpPr/>
-          <p:nvPr/>
-        </p:nvSpPr>
-        <p:spPr>
-          <a:xfrm>
-            <a:off x="768096" y="4709160"/>
-            <a:ext cx="5303520" cy="292608"/>
-          </a:xfrm>
-          <a:prstGeom prst="rect">
-            <a:avLst/>
-          </a:prstGeom>
-          <a:noFill/>
-          <a:ln/>
-        </p:spPr>
-        <p:txBody>
-          <a:bodyPr wrap="square" lIns="0" tIns="0" rIns="0" bIns="0" rtlCol="0" anchor="ctr">
-            <a:normAutofit/>
-          </a:bodyPr>
-          <a:lstStyle/>
-          <a:p>
-            <a:pPr marL="0" indent="0">
-              <a:buNone/>
-            </a:pPr>
-            <a:r>
-              <a:rPr lang="en-US" sz="1200" dirty="0">
-                <a:solidFill>
-                  <a:srgbClr val="C8D2E4"/>
-                </a:solidFill>
-                <a:latin typeface="Aptos" pitchFamily="34" charset="0"/>
-                <a:ea typeface="Aptos" pitchFamily="34" charset="-122"/>
-                <a:cs typeface="Aptos" pitchFamily="34" charset="-120"/>
-              </a:rPr>
-              <a:t>Advanced path: VS Code + GitHub Copilot</a:t>
-            </a:r>
-            <a:endParaRPr lang="en-US" sz="1200" dirty="0"/>
-          </a:p>
-        </p:txBody>
-      </p:sp>
-      <p:sp>
-        <p:nvSpPr>
-          <p:cNvPr id="12" name="Shape 10">
+            <a:off x="594360" y="2615184"/>
+            <a:ext cx="11059758" cy="3447289"/>
+          </a:xfrm>
+          <a:prstGeom prst="roundRect">
+            <a:avLst>
+              <a:gd name="adj" fmla="val 4062"/>
+            </a:avLst>
+          </a:prstGeom>
+          <a:solidFill>
+            <a:schemeClr val="bg1">
+              <a:lumMod val="85000"/>
+            </a:schemeClr>
+          </a:solidFill>
+        </p:spPr>
+        <p:style>
+          <a:lnRef idx="2">
+            <a:schemeClr val="accent1">
+              <a:shade val="15000"/>
+            </a:schemeClr>
+          </a:lnRef>
+          <a:fillRef idx="1">
+            <a:schemeClr val="accent1"/>
+          </a:fillRef>
+          <a:effectRef idx="0">
+            <a:schemeClr val="accent1"/>
+          </a:effectRef>
+          <a:fontRef idx="minor">
+            <a:schemeClr val="lt1"/>
+          </a:fontRef>
+        </p:style>
+        <p:txBody>
+          <a:bodyPr rtlCol="0" anchor="ctr"/>
+          <a:lstStyle/>
+          <a:p>
+            <a:pPr algn="ctr"/>
+            <a:endParaRPr lang="en-US" dirty="0"/>
+          </a:p>
+        </p:txBody>
+      </p:sp>
+      <p:sp>
+        <p:nvSpPr>
+          <p:cNvPr id="26" name="Text 5">
             <a:extLst>
-              <a:ext uri="{C183D7F6-B498-43B3-948B-1728B52AA6E4}">
-                <adec:decorative xmlns:adec="http://schemas.microsoft.com/office/drawing/2017/decorative" val="1"/>
+              <a:ext uri="{FF2B5EF4-FFF2-40B4-BE49-F238E27FC236}">
+                <a16:creationId xmlns:a16="http://schemas.microsoft.com/office/drawing/2014/main" id="{08510B24-1BFD-9367-3F17-0381849B1AB1}"/>
               </a:ext>
             </a:extLst>
           </p:cNvPr>
@@ -5745,79 +3690,42 @@
         </p:nvSpPr>
         <p:spPr>
           <a:xfrm>
-            <a:off x="768096" y="5413248"/>
-            <a:ext cx="1234440" cy="384048"/>
-          </a:xfrm>
-          <a:prstGeom prst="roundRect">
-            <a:avLst>
-              <a:gd name="adj" fmla="val 28571"/>
-            </a:avLst>
-          </a:prstGeom>
-          <a:solidFill>
-            <a:srgbClr val="4F6FAE"/>
-          </a:solidFill>
-          <a:ln w="12700">
-            <a:solidFill>
-              <a:srgbClr val="4F6FAE"/>
-            </a:solidFill>
-            <a:prstDash val="solid"/>
-          </a:ln>
-        </p:spPr>
-        <p:txBody>
-          <a:bodyPr/>
-          <a:lstStyle/>
-          <a:p>
-            <a:endParaRPr lang="en-US"/>
-          </a:p>
-        </p:txBody>
-      </p:sp>
-      <p:sp>
-        <p:nvSpPr>
-          <p:cNvPr id="13" name="Text 11"/>
-          <p:cNvSpPr/>
-          <p:nvPr/>
-        </p:nvSpPr>
-        <p:spPr>
-          <a:xfrm>
-            <a:off x="877824" y="5413248"/>
-            <a:ext cx="1014984" cy="384048"/>
-          </a:xfrm>
-          <a:prstGeom prst="rect">
-            <a:avLst/>
-          </a:prstGeom>
-          <a:noFill/>
-          <a:ln/>
-        </p:spPr>
-        <p:txBody>
-          <a:bodyPr wrap="square" lIns="0" tIns="0" rIns="0" bIns="0" rtlCol="0" anchor="ctr">
-            <a:normAutofit/>
-          </a:bodyPr>
-          <a:lstStyle/>
-          <a:p>
-            <a:pPr marL="0" indent="0" algn="ctr">
-              <a:buNone/>
-            </a:pPr>
-            <a:r>
-              <a:rPr lang="en-US" sz="1100" b="1" dirty="0">
-                <a:solidFill>
-                  <a:srgbClr val="FFFFFF"/>
-                </a:solidFill>
-                <a:latin typeface="Aptos" pitchFamily="34" charset="0"/>
-                <a:ea typeface="Aptos" pitchFamily="34" charset="-122"/>
-                <a:cs typeface="Aptos" pitchFamily="34" charset="-120"/>
-              </a:rPr>
-              <a:t>IDEATE</a:t>
-            </a:r>
-            <a:endParaRPr lang="en-US" sz="1100" dirty="0"/>
-          </a:p>
-        </p:txBody>
-      </p:sp>
-      <p:sp>
-        <p:nvSpPr>
-          <p:cNvPr id="14" name="Shape 12">
+            <a:off x="868680" y="2752344"/>
+            <a:ext cx="9602096" cy="594360"/>
+          </a:xfrm>
+          <a:prstGeom prst="rect">
+            <a:avLst/>
+          </a:prstGeom>
+          <a:noFill/>
+          <a:ln/>
+        </p:spPr>
+        <p:txBody>
+          <a:bodyPr wrap="square" lIns="0" tIns="0" rIns="0" bIns="0" rtlCol="0" anchor="ctr">
+            <a:normAutofit/>
+          </a:bodyPr>
+          <a:lstStyle/>
+          <a:p>
+            <a:pPr marL="0" indent="0">
+              <a:buNone/>
+            </a:pPr>
+            <a:r>
+              <a:rPr lang="en-US" sz="2100" b="1" dirty="0">
+                <a:latin typeface="Aptos" pitchFamily="34" charset="0"/>
+                <a:ea typeface="Aptos" pitchFamily="34" charset="-122"/>
+                <a:cs typeface="Aptos" pitchFamily="34" charset="-120"/>
+              </a:rPr>
+              <a:t>ACCESS THE PRESENTATION RESOURCE SITE AND PROMPT BUILDER APP</a:t>
+            </a:r>
+            <a:endParaRPr lang="en-US" sz="2100" b="1" dirty="0"/>
+          </a:p>
+        </p:txBody>
+      </p:sp>
+      <p:sp>
+        <p:nvSpPr>
+          <p:cNvPr id="28" name="Text 5">
             <a:extLst>
-              <a:ext uri="{C183D7F6-B498-43B3-948B-1728B52AA6E4}">
-                <adec:decorative xmlns:adec="http://schemas.microsoft.com/office/drawing/2017/decorative" val="1"/>
+              <a:ext uri="{FF2B5EF4-FFF2-40B4-BE49-F238E27FC236}">
+                <a16:creationId xmlns:a16="http://schemas.microsoft.com/office/drawing/2014/main" id="{7B7FCFC5-57E4-BCF0-1B3C-BBD235D71835}"/>
               </a:ext>
             </a:extLst>
           </p:cNvPr>
@@ -5826,164 +3734,8 @@
         </p:nvSpPr>
         <p:spPr>
           <a:xfrm>
-            <a:off x="2176272" y="5413248"/>
-            <a:ext cx="1325880" cy="384048"/>
-          </a:xfrm>
-          <a:prstGeom prst="roundRect">
-            <a:avLst>
-              <a:gd name="adj" fmla="val 28571"/>
-            </a:avLst>
-          </a:prstGeom>
-          <a:solidFill>
-            <a:srgbClr val="D5B979"/>
-          </a:solidFill>
-          <a:ln w="12700">
-            <a:solidFill>
-              <a:srgbClr val="D5B979"/>
-            </a:solidFill>
-            <a:prstDash val="solid"/>
-          </a:ln>
-        </p:spPr>
-        <p:txBody>
-          <a:bodyPr/>
-          <a:lstStyle/>
-          <a:p>
-            <a:endParaRPr lang="en-US"/>
-          </a:p>
-        </p:txBody>
-      </p:sp>
-      <p:sp>
-        <p:nvSpPr>
-          <p:cNvPr id="15" name="Text 13"/>
-          <p:cNvSpPr/>
-          <p:nvPr/>
-        </p:nvSpPr>
-        <p:spPr>
-          <a:xfrm>
-            <a:off x="2286000" y="5413248"/>
-            <a:ext cx="1106424" cy="384048"/>
-          </a:xfrm>
-          <a:prstGeom prst="rect">
-            <a:avLst/>
-          </a:prstGeom>
-          <a:noFill/>
-          <a:ln/>
-        </p:spPr>
-        <p:txBody>
-          <a:bodyPr wrap="square" lIns="0" tIns="0" rIns="0" bIns="0" rtlCol="0" anchor="ctr">
-            <a:normAutofit/>
-          </a:bodyPr>
-          <a:lstStyle/>
-          <a:p>
-            <a:pPr marL="0" indent="0" algn="ctr">
-              <a:buNone/>
-            </a:pPr>
-            <a:r>
-              <a:rPr lang="en-US" sz="1100" b="1" dirty="0">
-                <a:solidFill>
-                  <a:srgbClr val="17254E"/>
-                </a:solidFill>
-                <a:latin typeface="Aptos" pitchFamily="34" charset="0"/>
-                <a:ea typeface="Aptos" pitchFamily="34" charset="-122"/>
-                <a:cs typeface="Aptos" pitchFamily="34" charset="-120"/>
-              </a:rPr>
-              <a:t>ITERATE</a:t>
-            </a:r>
-            <a:endParaRPr lang="en-US" sz="1100" dirty="0"/>
-          </a:p>
-        </p:txBody>
-      </p:sp>
-      <p:sp>
-        <p:nvSpPr>
-          <p:cNvPr id="16" name="Shape 14">
-            <a:extLst>
-              <a:ext uri="{C183D7F6-B498-43B3-948B-1728B52AA6E4}">
-                <adec:decorative xmlns:adec="http://schemas.microsoft.com/office/drawing/2017/decorative" val="1"/>
-              </a:ext>
-            </a:extLst>
-          </p:cNvPr>
-          <p:cNvSpPr/>
-          <p:nvPr/>
-        </p:nvSpPr>
-        <p:spPr>
-          <a:xfrm>
-            <a:off x="3675888" y="5413248"/>
-            <a:ext cx="1508760" cy="384048"/>
-          </a:xfrm>
-          <a:prstGeom prst="roundRect">
-            <a:avLst>
-              <a:gd name="adj" fmla="val 28571"/>
-            </a:avLst>
-          </a:prstGeom>
-          <a:solidFill>
-            <a:srgbClr val="149966"/>
-          </a:solidFill>
-          <a:ln w="12700">
-            <a:solidFill>
-              <a:srgbClr val="149966"/>
-            </a:solidFill>
-            <a:prstDash val="solid"/>
-          </a:ln>
-        </p:spPr>
-        <p:txBody>
-          <a:bodyPr/>
-          <a:lstStyle/>
-          <a:p>
-            <a:endParaRPr lang="en-US"/>
-          </a:p>
-        </p:txBody>
-      </p:sp>
-      <p:sp>
-        <p:nvSpPr>
-          <p:cNvPr id="17" name="Text 15"/>
-          <p:cNvSpPr/>
-          <p:nvPr/>
-        </p:nvSpPr>
-        <p:spPr>
-          <a:xfrm>
-            <a:off x="3785616" y="5413248"/>
-            <a:ext cx="1289304" cy="384048"/>
-          </a:xfrm>
-          <a:prstGeom prst="rect">
-            <a:avLst/>
-          </a:prstGeom>
-          <a:noFill/>
-          <a:ln/>
-        </p:spPr>
-        <p:txBody>
-          <a:bodyPr wrap="square" lIns="0" tIns="0" rIns="0" bIns="0" rtlCol="0" anchor="ctr">
-            <a:normAutofit/>
-          </a:bodyPr>
-          <a:lstStyle/>
-          <a:p>
-            <a:pPr marL="0" indent="0" algn="ctr">
-              <a:buNone/>
-            </a:pPr>
-            <a:r>
-              <a:rPr lang="en-US" sz="1100" b="1" dirty="0">
-                <a:solidFill>
-                  <a:srgbClr val="FFFFFF"/>
-                </a:solidFill>
-                <a:latin typeface="Aptos" pitchFamily="34" charset="0"/>
-                <a:ea typeface="Aptos" pitchFamily="34" charset="-122"/>
-                <a:cs typeface="Aptos" pitchFamily="34" charset="-120"/>
-              </a:rPr>
-              <a:t>IMPLEMENT</a:t>
-            </a:r>
-            <a:endParaRPr lang="en-US" sz="1100" dirty="0"/>
-          </a:p>
-        </p:txBody>
-      </p:sp>
-      <p:sp>
-        <p:nvSpPr>
-          <p:cNvPr id="2" name="Text 0"/>
-          <p:cNvSpPr/>
-          <p:nvPr/>
-        </p:nvSpPr>
-        <p:spPr>
-          <a:xfrm>
-            <a:off x="594360" y="6510528"/>
-            <a:ext cx="5943600" cy="164592"/>
+            <a:off x="868680" y="3289330"/>
+            <a:ext cx="9602096" cy="2270221"/>
           </a:xfrm>
           <a:prstGeom prst="rect">
             <a:avLst/>
@@ -6001,17 +3753,63 @@
               <a:buNone/>
             </a:pPr>
             <a:r>
-              <a:rPr lang="en-US" sz="800" dirty="0">
-                <a:solidFill>
-                  <a:srgbClr val="BFC9DB"/>
-                </a:solidFill>
-                <a:latin typeface="Aptos" pitchFamily="34" charset="0"/>
-                <a:ea typeface="Aptos" pitchFamily="34" charset="-122"/>
-                <a:cs typeface="Aptos" pitchFamily="34" charset="-120"/>
-              </a:rPr>
-              <a:t>Hillsborough College  |  Summer Institute 2026</a:t>
-            </a:r>
-            <a:endParaRPr lang="en-US" sz="800" dirty="0"/>
+              <a:rPr lang="en-US" sz="2100" dirty="0">
+                <a:latin typeface="Aptos" pitchFamily="34" charset="0"/>
+                <a:ea typeface="Aptos" pitchFamily="34" charset="-122"/>
+                <a:cs typeface="Aptos" pitchFamily="34" charset="-120"/>
+              </a:rPr>
+              <a:t>Visit the </a:t>
+            </a:r>
+            <a:r>
+              <a:rPr lang="en-US" sz="2100" dirty="0">
+                <a:latin typeface="Aptos" pitchFamily="34" charset="0"/>
+                <a:ea typeface="Aptos" pitchFamily="34" charset="-122"/>
+                <a:cs typeface="Aptos" pitchFamily="34" charset="-120"/>
+                <a:hlinkClick r:id="rId3"/>
+              </a:rPr>
+              <a:t>resource site</a:t>
+            </a:r>
+            <a:r>
+              <a:rPr lang="en-US" sz="2100" dirty="0">
+                <a:latin typeface="Aptos" pitchFamily="34" charset="0"/>
+                <a:ea typeface="Aptos" pitchFamily="34" charset="-122"/>
+                <a:cs typeface="Aptos" pitchFamily="34" charset="-120"/>
+              </a:rPr>
+              <a:t> to view and print presentation handouts and case studies at your leisure. </a:t>
+            </a:r>
+          </a:p>
+          <a:p>
+            <a:pPr marL="0" indent="0">
+              <a:buNone/>
+            </a:pPr>
+            <a:endParaRPr lang="en-US" sz="2100" dirty="0">
+              <a:latin typeface="Aptos" pitchFamily="34" charset="0"/>
+            </a:endParaRPr>
+          </a:p>
+          <a:p>
+            <a:pPr marL="0" indent="0">
+              <a:buNone/>
+            </a:pPr>
+            <a:r>
+              <a:rPr lang="en-US" sz="2100" dirty="0">
+                <a:latin typeface="Aptos" pitchFamily="34" charset="0"/>
+              </a:rPr>
+              <a:t>Your also welcome to use this </a:t>
+            </a:r>
+            <a:r>
+              <a:rPr lang="en-US" sz="2100" dirty="0">
+                <a:latin typeface="Aptos" pitchFamily="34" charset="0"/>
+                <a:hlinkClick r:id="rId3"/>
+              </a:rPr>
+              <a:t>prompt and context builder app</a:t>
+            </a:r>
+            <a:r>
+              <a:rPr lang="en-US" sz="2100" dirty="0">
+                <a:latin typeface="Aptos" pitchFamily="34" charset="0"/>
+              </a:rPr>
+              <a:t> that’s based on the workflow and model discussed in this same presentation.</a:t>
+            </a:r>
+            <a:endParaRPr lang="en-US" sz="2100" dirty="0"/>
           </a:p>
         </p:txBody>
       </p:sp>
@@ -20566,87 +18364,6 @@
       </p:sp>
       <p:sp>
         <p:nvSpPr>
-          <p:cNvPr id="3" name="Shape 1">
-            <a:extLst>
-              <a:ext uri="{C183D7F6-B498-43B3-948B-1728B52AA6E4}">
-                <adec:decorative xmlns:adec="http://schemas.microsoft.com/office/drawing/2017/decorative" val="1"/>
-              </a:ext>
-            </a:extLst>
-          </p:cNvPr>
-          <p:cNvSpPr/>
-          <p:nvPr/>
-        </p:nvSpPr>
-        <p:spPr>
-          <a:xfrm>
-            <a:off x="594360" y="246888"/>
-            <a:ext cx="1325880" cy="347472"/>
-          </a:xfrm>
-          <a:prstGeom prst="roundRect">
-            <a:avLst>
-              <a:gd name="adj" fmla="val 23684"/>
-            </a:avLst>
-          </a:prstGeom>
-          <a:solidFill>
-            <a:srgbClr val="149966"/>
-          </a:solidFill>
-          <a:ln w="12700">
-            <a:solidFill>
-              <a:srgbClr val="149966"/>
-            </a:solidFill>
-            <a:prstDash val="solid"/>
-          </a:ln>
-        </p:spPr>
-        <p:txBody>
-          <a:bodyPr/>
-          <a:lstStyle/>
-          <a:p>
-            <a:endParaRPr lang="en-US"/>
-          </a:p>
-        </p:txBody>
-      </p:sp>
-      <p:sp>
-        <p:nvSpPr>
-          <p:cNvPr id="4" name="Text 2"/>
-          <p:cNvSpPr/>
-          <p:nvPr/>
-        </p:nvSpPr>
-        <p:spPr>
-          <a:xfrm>
-            <a:off x="667512" y="246888"/>
-            <a:ext cx="1179576" cy="347472"/>
-          </a:xfrm>
-          <a:prstGeom prst="rect">
-            <a:avLst/>
-          </a:prstGeom>
-          <a:noFill/>
-          <a:ln/>
-        </p:spPr>
-        <p:txBody>
-          <a:bodyPr wrap="square" lIns="0" tIns="0" rIns="0" bIns="0" rtlCol="0" anchor="ctr">
-            <a:normAutofit/>
-          </a:bodyPr>
-          <a:lstStyle/>
-          <a:p>
-            <a:pPr marL="0" indent="0" algn="ctr">
-              <a:buNone/>
-            </a:pPr>
-            <a:r>
-              <a:rPr lang="en-US" sz="900" b="1" kern="0" spc="120" dirty="0">
-                <a:solidFill>
-                  <a:srgbClr val="FFFFFF"/>
-                </a:solidFill>
-                <a:latin typeface="Aptos" pitchFamily="34" charset="0"/>
-                <a:ea typeface="Aptos" pitchFamily="34" charset="-122"/>
-                <a:cs typeface="Aptos" pitchFamily="34" charset="-120"/>
-              </a:rPr>
-              <a:t>IMPLEMENT</a:t>
-            </a:r>
-            <a:endParaRPr lang="en-US" sz="900" dirty="0"/>
-          </a:p>
-        </p:txBody>
-      </p:sp>
-      <p:sp>
-        <p:nvSpPr>
           <p:cNvPr id="6" name="Text 4"/>
           <p:cNvSpPr/>
           <p:nvPr/>
@@ -21487,6 +19204,96 @@
               <a:t>Hillsborough College  |  Summer Institute 2026</a:t>
             </a:r>
             <a:endParaRPr lang="en-US" sz="800" dirty="0"/>
+          </a:p>
+        </p:txBody>
+      </p:sp>
+      <p:sp>
+        <p:nvSpPr>
+          <p:cNvPr id="12" name="Shape 1">
+            <a:extLst>
+              <a:ext uri="{FF2B5EF4-FFF2-40B4-BE49-F238E27FC236}">
+                <a16:creationId xmlns:a16="http://schemas.microsoft.com/office/drawing/2014/main" id="{B3A9AF9A-061B-5BBD-969B-6F3256982E65}"/>
+              </a:ext>
+              <a:ext uri="{C183D7F6-B498-43B3-948B-1728B52AA6E4}">
+                <adec:decorative xmlns:adec="http://schemas.microsoft.com/office/drawing/2017/decorative" val="1"/>
+              </a:ext>
+            </a:extLst>
+          </p:cNvPr>
+          <p:cNvSpPr/>
+          <p:nvPr/>
+        </p:nvSpPr>
+        <p:spPr>
+          <a:xfrm>
+            <a:off x="594360" y="246888"/>
+            <a:ext cx="1325880" cy="347472"/>
+          </a:xfrm>
+          <a:prstGeom prst="roundRect">
+            <a:avLst>
+              <a:gd name="adj" fmla="val 23684"/>
+            </a:avLst>
+          </a:prstGeom>
+          <a:solidFill>
+            <a:schemeClr val="accent2"/>
+          </a:solidFill>
+          <a:ln w="12700">
+            <a:solidFill>
+              <a:schemeClr val="accent2"/>
+            </a:solidFill>
+            <a:prstDash val="solid"/>
+          </a:ln>
+        </p:spPr>
+        <p:txBody>
+          <a:bodyPr/>
+          <a:lstStyle/>
+          <a:p>
+            <a:endParaRPr lang="en-US"/>
+          </a:p>
+        </p:txBody>
+      </p:sp>
+      <p:sp>
+        <p:nvSpPr>
+          <p:cNvPr id="28" name="Text 2">
+            <a:extLst>
+              <a:ext uri="{FF2B5EF4-FFF2-40B4-BE49-F238E27FC236}">
+                <a16:creationId xmlns:a16="http://schemas.microsoft.com/office/drawing/2014/main" id="{451DB6DC-4810-2B8C-34FA-0A12EC8C80F7}"/>
+              </a:ext>
+            </a:extLst>
+          </p:cNvPr>
+          <p:cNvSpPr/>
+          <p:nvPr/>
+        </p:nvSpPr>
+        <p:spPr>
+          <a:xfrm>
+            <a:off x="667512" y="246888"/>
+            <a:ext cx="1179576" cy="347472"/>
+          </a:xfrm>
+          <a:prstGeom prst="rect">
+            <a:avLst/>
+          </a:prstGeom>
+          <a:noFill/>
+          <a:ln/>
+        </p:spPr>
+        <p:txBody>
+          <a:bodyPr wrap="square" lIns="0" tIns="0" rIns="0" bIns="0" rtlCol="0" anchor="ctr">
+            <a:normAutofit/>
+          </a:bodyPr>
+          <a:lstStyle/>
+          <a:p>
+            <a:pPr marL="0" indent="0" algn="ctr">
+              <a:buNone/>
+            </a:pPr>
+            <a:r>
+              <a:rPr lang="en-US" sz="900" b="1" kern="0" spc="120" dirty="0">
+                <a:solidFill>
+                  <a:srgbClr val="FFFFFF"/>
+                </a:solidFill>
+                <a:latin typeface="Aptos" pitchFamily="34" charset="0"/>
+                <a:ea typeface="Aptos" pitchFamily="34" charset="-122"/>
+                <a:cs typeface="Aptos" pitchFamily="34" charset="-120"/>
+              </a:rPr>
+              <a:t>BRASS TACKS</a:t>
+            </a:r>
+            <a:endParaRPr lang="en-US" sz="900" dirty="0"/>
           </a:p>
         </p:txBody>
       </p:sp>

</xml_diff>